<commit_message>
Rebuild both decks with card renders, wallet mockups, and QR codes
Embedded images in both PowerPoint decks:
- Physical card front/back renders (gold Nighthawk design)
- Apple Wallet pass mockup (iPhone with gold pass + QR code)
- Scan verification screen (green VALID with holder name)
- Fraud warning screen (yellow with rate limit alerts)
- Sponsor dashboard mockup (Board & Brew example data)
- Claim page mockup (mobile Add to Wallet flow)
- Sample navy-blue QR code

Sponsor deck: 13 slides, 501KB
Board deck: 6 slides, 376KB

Co-Authored-By: Claude Opus 4.6 (1M context) <noreply@anthropic.com>
</commit_message>
<xml_diff>
--- a/pitch/Del-Norte-Board-Approval.pptx
+++ b/pitch/Del-Norte-Board-Approval.pptx
@@ -1640,7 +1640,7 @@
                 <a:ea typeface="Arial Black" pitchFamily="34" charset="-122"/>
                 <a:cs typeface="Arial Black" pitchFamily="34" charset="-120"/>
               </a:rPr>
-              <a:t>THE PROBLEM AND THE SOLUTION</a:t>
+              <a:t>WHAT IT LOOKS LIKE</a:t>
             </a:r>
             <a:endParaRPr lang="en-US" sz="2400" dirty="0"/>
           </a:p>
@@ -1648,116 +1648,279 @@
       </p:sp>
       <p:sp>
         <p:nvSpPr>
-          <p:cNvPr id="4" name="Shape 2"/>
-          <p:cNvSpPr/>
-          <p:nvPr/>
-        </p:nvSpPr>
-        <p:spPr>
-          <a:xfrm>
-            <a:off x="548640" y="1280160"/>
-            <a:ext cx="3840480" cy="3474720"/>
-          </a:xfrm>
-          <a:prstGeom prst="rect">
-            <a:avLst/>
-          </a:prstGeom>
-          <a:solidFill>
-            <a:srgbClr val="FFF5F5"/>
-          </a:solidFill>
-          <a:ln/>
-          <a:effectLst>
-            <a:outerShdw sx="100000" sy="100000" kx="0" ky="0" algn="bl" rotWithShape="0" blurRad="101600" dist="38100" dir="8100000">
-              <a:srgbClr val="000000">
-                <a:alpha val="20000"/>
-              </a:srgbClr>
-            </a:outerShdw>
-          </a:effectLst>
-        </p:spPr>
-      </p:sp>
-      <p:sp>
-        <p:nvSpPr>
-          <p:cNvPr id="5" name="Shape 3"/>
-          <p:cNvSpPr/>
-          <p:nvPr/>
-        </p:nvSpPr>
-        <p:spPr>
-          <a:xfrm>
-            <a:off x="548640" y="1280160"/>
-            <a:ext cx="3840480" cy="54864"/>
-          </a:xfrm>
-          <a:prstGeom prst="rect">
-            <a:avLst/>
-          </a:prstGeom>
-          <a:solidFill>
-            <a:srgbClr val="CC0000"/>
-          </a:solidFill>
-          <a:ln/>
-        </p:spPr>
-      </p:sp>
-      <p:sp>
-        <p:nvSpPr>
-          <p:cNvPr id="6" name="Text 4"/>
-          <p:cNvSpPr/>
-          <p:nvPr/>
-        </p:nvSpPr>
-        <p:spPr>
-          <a:xfrm>
-            <a:off x="822960" y="1463040"/>
-            <a:ext cx="3291840" cy="365760"/>
-          </a:xfrm>
-          <a:prstGeom prst="rect">
-            <a:avLst/>
-          </a:prstGeom>
-          <a:noFill/>
-          <a:ln/>
-        </p:spPr>
-        <p:txBody>
-          <a:bodyPr wrap="square" lIns="0" tIns="0" rIns="0" bIns="0" rtlCol="0" anchor="ctr"/>
-          <a:lstStyle/>
-          <a:p>
-            <a:pPr indent="0" marL="0">
-              <a:buNone/>
-            </a:pPr>
-            <a:r>
-              <a:rPr lang="en-US" sz="1300" b="1" dirty="0">
-                <a:solidFill>
-                  <a:srgbClr val="CC0000"/>
-                </a:solidFill>
-                <a:latin typeface="Arial" pitchFamily="34" charset="0"/>
-                <a:ea typeface="Arial" pitchFamily="34" charset="-122"/>
-                <a:cs typeface="Arial" pitchFamily="34" charset="-120"/>
-              </a:rPr>
-              <a:t>CURRENT: PHYSICAL CARD</a:t>
-            </a:r>
-            <a:endParaRPr lang="en-US" sz="1300" dirty="0"/>
-          </a:p>
-        </p:txBody>
-      </p:sp>
-      <p:sp>
-        <p:nvSpPr>
-          <p:cNvPr id="7" name="Text 5"/>
-          <p:cNvSpPr/>
-          <p:nvPr/>
-        </p:nvSpPr>
-        <p:spPr>
-          <a:xfrm>
-            <a:off x="822960" y="1920240"/>
-            <a:ext cx="3291840" cy="365760"/>
-          </a:xfrm>
-          <a:prstGeom prst="rect">
-            <a:avLst/>
-          </a:prstGeom>
-          <a:noFill/>
-          <a:ln/>
-        </p:spPr>
-        <p:txBody>
-          <a:bodyPr wrap="square" lIns="0" tIns="0" rIns="0" bIns="0" rtlCol="0" anchor="ctr"/>
-          <a:lstStyle/>
-          <a:p>
-            <a:pPr indent="0" marL="0">
-              <a:buNone/>
-            </a:pPr>
-            <a:r>
-              <a:rPr lang="en-US" sz="1200" dirty="0">
+          <p:cNvPr id="4" name="Text 2"/>
+          <p:cNvSpPr/>
+          <p:nvPr/>
+        </p:nvSpPr>
+        <p:spPr>
+          <a:xfrm>
+            <a:off x="274320" y="1097280"/>
+            <a:ext cx="3200400" cy="274320"/>
+          </a:xfrm>
+          <a:prstGeom prst="rect">
+            <a:avLst/>
+          </a:prstGeom>
+          <a:noFill/>
+          <a:ln/>
+        </p:spPr>
+        <p:txBody>
+          <a:bodyPr wrap="square" lIns="0" tIns="0" rIns="0" bIns="0" rtlCol="0" anchor="ctr"/>
+          <a:lstStyle/>
+          <a:p>
+            <a:pPr algn="ctr" indent="0" marL="0">
+              <a:buNone/>
+            </a:pPr>
+            <a:r>
+              <a:rPr lang="en-US" sz="1000" b="1" dirty="0">
+                <a:solidFill>
+                  <a:srgbClr val="002D62"/>
+                </a:solidFill>
+                <a:latin typeface="Arial" pitchFamily="34" charset="0"/>
+                <a:ea typeface="Arial" pitchFamily="34" charset="-122"/>
+                <a:cs typeface="Arial" pitchFamily="34" charset="-120"/>
+              </a:rPr>
+              <a:t>Physical Card (Front)</a:t>
+            </a:r>
+            <a:endParaRPr lang="en-US" sz="1000" dirty="0"/>
+          </a:p>
+        </p:txBody>
+      </p:sp>
+      <p:pic>
+        <p:nvPicPr>
+          <p:cNvPr id="5" name="Image 0" descr="preencoded.png">    </p:cNvPr>
+          <p:cNvPicPr>
+            <a:picLocks noChangeAspect="1"/>
+          </p:cNvPicPr>
+          <p:nvPr/>
+        </p:nvPicPr>
+        <p:blipFill>
+          <a:blip r:embed="rId1"/>
+          <a:srcRect l="0" r="0" t="0" b="0"/>
+          <a:stretch/>
+        </p:blipFill>
+        <p:spPr>
+          <a:xfrm>
+            <a:off x="274320" y="1371600"/>
+            <a:ext cx="3200400" cy="1828800"/>
+          </a:xfrm>
+          <a:prstGeom prst="rect">
+            <a:avLst/>
+          </a:prstGeom>
+        </p:spPr>
+      </p:pic>
+      <p:sp>
+        <p:nvSpPr>
+          <p:cNvPr id="6" name="Text 3"/>
+          <p:cNvSpPr/>
+          <p:nvPr/>
+        </p:nvSpPr>
+        <p:spPr>
+          <a:xfrm>
+            <a:off x="274320" y="3291840"/>
+            <a:ext cx="3200400" cy="274320"/>
+          </a:xfrm>
+          <a:prstGeom prst="rect">
+            <a:avLst/>
+          </a:prstGeom>
+          <a:noFill/>
+          <a:ln/>
+        </p:spPr>
+        <p:txBody>
+          <a:bodyPr wrap="square" lIns="0" tIns="0" rIns="0" bIns="0" rtlCol="0" anchor="ctr"/>
+          <a:lstStyle/>
+          <a:p>
+            <a:pPr algn="ctr" indent="0" marL="0">
+              <a:buNone/>
+            </a:pPr>
+            <a:r>
+              <a:rPr lang="en-US" sz="1000" b="1" dirty="0">
+                <a:solidFill>
+                  <a:srgbClr val="002D62"/>
+                </a:solidFill>
+                <a:latin typeface="Arial" pitchFamily="34" charset="0"/>
+                <a:ea typeface="Arial" pitchFamily="34" charset="-122"/>
+                <a:cs typeface="Arial" pitchFamily="34" charset="-120"/>
+              </a:rPr>
+              <a:t>Physical Card (Back) with Unique QR</a:t>
+            </a:r>
+            <a:endParaRPr lang="en-US" sz="1000" dirty="0"/>
+          </a:p>
+        </p:txBody>
+      </p:sp>
+      <p:pic>
+        <p:nvPicPr>
+          <p:cNvPr id="7" name="Image 1" descr="preencoded.png">    </p:cNvPr>
+          <p:cNvPicPr>
+            <a:picLocks noChangeAspect="1"/>
+          </p:cNvPicPr>
+          <p:nvPr/>
+        </p:nvPicPr>
+        <p:blipFill>
+          <a:blip r:embed="rId2"/>
+          <a:srcRect l="0" r="0" t="0" b="0"/>
+          <a:stretch/>
+        </p:blipFill>
+        <p:spPr>
+          <a:xfrm>
+            <a:off x="274320" y="3566160"/>
+            <a:ext cx="3200400" cy="1371600"/>
+          </a:xfrm>
+          <a:prstGeom prst="rect">
+            <a:avLst/>
+          </a:prstGeom>
+        </p:spPr>
+      </p:pic>
+      <p:sp>
+        <p:nvSpPr>
+          <p:cNvPr id="8" name="Text 4"/>
+          <p:cNvSpPr/>
+          <p:nvPr/>
+        </p:nvSpPr>
+        <p:spPr>
+          <a:xfrm>
+            <a:off x="3840480" y="1097280"/>
+            <a:ext cx="2103120" cy="274320"/>
+          </a:xfrm>
+          <a:prstGeom prst="rect">
+            <a:avLst/>
+          </a:prstGeom>
+          <a:noFill/>
+          <a:ln/>
+        </p:spPr>
+        <p:txBody>
+          <a:bodyPr wrap="square" lIns="0" tIns="0" rIns="0" bIns="0" rtlCol="0" anchor="ctr"/>
+          <a:lstStyle/>
+          <a:p>
+            <a:pPr algn="ctr" indent="0" marL="0">
+              <a:buNone/>
+            </a:pPr>
+            <a:r>
+              <a:rPr lang="en-US" sz="1000" b="1" dirty="0">
+                <a:solidFill>
+                  <a:srgbClr val="002D62"/>
+                </a:solidFill>
+                <a:latin typeface="Arial" pitchFamily="34" charset="0"/>
+                <a:ea typeface="Arial" pitchFamily="34" charset="-122"/>
+                <a:cs typeface="Arial" pitchFamily="34" charset="-120"/>
+              </a:rPr>
+              <a:t>Apple Wallet Version</a:t>
+            </a:r>
+            <a:endParaRPr lang="en-US" sz="1000" dirty="0"/>
+          </a:p>
+        </p:txBody>
+      </p:sp>
+      <p:pic>
+        <p:nvPicPr>
+          <p:cNvPr id="9" name="Image 2" descr="preencoded.png">    </p:cNvPr>
+          <p:cNvPicPr>
+            <a:picLocks noChangeAspect="1"/>
+          </p:cNvPicPr>
+          <p:nvPr/>
+        </p:nvPicPr>
+        <p:blipFill>
+          <a:blip r:embed="rId3"/>
+          <a:srcRect l="0" r="0" t="0" b="0"/>
+          <a:stretch/>
+        </p:blipFill>
+        <p:spPr>
+          <a:xfrm>
+            <a:off x="3840480" y="1371600"/>
+            <a:ext cx="2103120" cy="3255264"/>
+          </a:xfrm>
+          <a:prstGeom prst="rect">
+            <a:avLst/>
+          </a:prstGeom>
+        </p:spPr>
+      </p:pic>
+      <p:sp>
+        <p:nvSpPr>
+          <p:cNvPr id="10" name="Text 5"/>
+          <p:cNvSpPr/>
+          <p:nvPr/>
+        </p:nvSpPr>
+        <p:spPr>
+          <a:xfrm>
+            <a:off x="6583680" y="1097280"/>
+            <a:ext cx="2103120" cy="274320"/>
+          </a:xfrm>
+          <a:prstGeom prst="rect">
+            <a:avLst/>
+          </a:prstGeom>
+          <a:noFill/>
+          <a:ln/>
+        </p:spPr>
+        <p:txBody>
+          <a:bodyPr wrap="square" lIns="0" tIns="0" rIns="0" bIns="0" rtlCol="0" anchor="ctr"/>
+          <a:lstStyle/>
+          <a:p>
+            <a:pPr algn="ctr" indent="0" marL="0">
+              <a:buNone/>
+            </a:pPr>
+            <a:r>
+              <a:rPr lang="en-US" sz="1000" b="1" dirty="0">
+                <a:solidFill>
+                  <a:srgbClr val="002D62"/>
+                </a:solidFill>
+                <a:latin typeface="Arial" pitchFamily="34" charset="0"/>
+                <a:ea typeface="Arial" pitchFamily="34" charset="-122"/>
+                <a:cs typeface="Arial" pitchFamily="34" charset="-120"/>
+              </a:rPr>
+              <a:t>Unique QR Code</a:t>
+            </a:r>
+            <a:endParaRPr lang="en-US" sz="1000" dirty="0"/>
+          </a:p>
+        </p:txBody>
+      </p:sp>
+      <p:pic>
+        <p:nvPicPr>
+          <p:cNvPr id="11" name="Image 3" descr="preencoded.png">    </p:cNvPr>
+          <p:cNvPicPr>
+            <a:picLocks noChangeAspect="1"/>
+          </p:cNvPicPr>
+          <p:nvPr/>
+        </p:nvPicPr>
+        <p:blipFill>
+          <a:blip r:embed="rId4"/>
+          <a:stretch>
+            <a:fillRect/>
+          </a:stretch>
+        </p:blipFill>
+        <p:spPr>
+          <a:xfrm>
+            <a:off x="6858000" y="1463040"/>
+            <a:ext cx="1645920" cy="1645920"/>
+          </a:xfrm>
+          <a:prstGeom prst="rect">
+            <a:avLst/>
+          </a:prstGeom>
+        </p:spPr>
+      </p:pic>
+      <p:sp>
+        <p:nvSpPr>
+          <p:cNvPr id="12" name="Text 6"/>
+          <p:cNvSpPr/>
+          <p:nvPr/>
+        </p:nvSpPr>
+        <p:spPr>
+          <a:xfrm>
+            <a:off x="6400800" y="3200400"/>
+            <a:ext cx="2560320" cy="731520"/>
+          </a:xfrm>
+          <a:prstGeom prst="rect">
+            <a:avLst/>
+          </a:prstGeom>
+          <a:noFill/>
+          <a:ln/>
+        </p:spPr>
+        <p:txBody>
+          <a:bodyPr wrap="square" lIns="0" tIns="0" rIns="0" bIns="0" rtlCol="0" anchor="ctr"/>
+          <a:lstStyle/>
+          <a:p>
+            <a:pPr algn="ctr" indent="0" marL="0">
+              <a:buNone/>
+            </a:pPr>
+            <a:r>
+              <a:rPr lang="en-US" sz="1000" dirty="0">
                 <a:solidFill>
                   <a:srgbClr val="666666"/>
                 </a:solidFill>
@@ -1765,38 +1928,16 @@
                 <a:ea typeface="Arial" pitchFamily="34" charset="-122"/>
                 <a:cs typeface="Arial" pitchFamily="34" charset="-120"/>
               </a:rPr>
-              <a:t>  Costs money to print every year</a:t>
-            </a:r>
-            <a:endParaRPr lang="en-US" sz="1200" dirty="0"/>
-          </a:p>
-        </p:txBody>
-      </p:sp>
-      <p:sp>
-        <p:nvSpPr>
-          <p:cNvPr id="8" name="Text 6"/>
-          <p:cNvSpPr/>
-          <p:nvPr/>
-        </p:nvSpPr>
-        <p:spPr>
-          <a:xfrm>
-            <a:off x="822960" y="2331720"/>
-            <a:ext cx="3291840" cy="365760"/>
-          </a:xfrm>
-          <a:prstGeom prst="rect">
-            <a:avLst/>
-          </a:prstGeom>
-          <a:noFill/>
-          <a:ln/>
-        </p:spPr>
-        <p:txBody>
-          <a:bodyPr wrap="square" lIns="0" tIns="0" rIns="0" bIns="0" rtlCol="0" anchor="ctr"/>
-          <a:lstStyle/>
-          <a:p>
-            <a:pPr indent="0" marL="0">
-              <a:buNone/>
-            </a:pPr>
-            <a:r>
-              <a:rPr lang="en-US" sz="1200" dirty="0">
+              <a:t>Each card gets a different</a:t>
+            </a:r>
+            <a:endParaRPr lang="en-US" sz="1000" dirty="0"/>
+          </a:p>
+          <a:p>
+            <a:pPr algn="ctr" indent="0" marL="0">
+              <a:buNone/>
+            </a:pPr>
+            <a:r>
+              <a:rPr lang="en-US" sz="1000" dirty="0">
                 <a:solidFill>
                   <a:srgbClr val="666666"/>
                 </a:solidFill>
@@ -1804,38 +1945,16 @@
                 <a:ea typeface="Arial" pitchFamily="34" charset="-122"/>
                 <a:cs typeface="Arial" pitchFamily="34" charset="-120"/>
               </a:rPr>
-              <a:t>  Gets lost or forgotten at home</a:t>
-            </a:r>
-            <a:endParaRPr lang="en-US" sz="1200" dirty="0"/>
-          </a:p>
-        </p:txBody>
-      </p:sp>
-      <p:sp>
-        <p:nvSpPr>
-          <p:cNvPr id="9" name="Text 7"/>
-          <p:cNvSpPr/>
-          <p:nvPr/>
-        </p:nvSpPr>
-        <p:spPr>
-          <a:xfrm>
-            <a:off x="822960" y="2743200"/>
-            <a:ext cx="3291840" cy="365760"/>
-          </a:xfrm>
-          <a:prstGeom prst="rect">
-            <a:avLst/>
-          </a:prstGeom>
-          <a:noFill/>
-          <a:ln/>
-        </p:spPr>
-        <p:txBody>
-          <a:bodyPr wrap="square" lIns="0" tIns="0" rIns="0" bIns="0" rtlCol="0" anchor="ctr"/>
-          <a:lstStyle/>
-          <a:p>
-            <a:pPr indent="0" marL="0">
-              <a:buNone/>
-            </a:pPr>
-            <a:r>
-              <a:rPr lang="en-US" sz="1200" dirty="0">
+              <a:t>QR code linking physical</a:t>
+            </a:r>
+            <a:endParaRPr lang="en-US" sz="1000" dirty="0"/>
+          </a:p>
+          <a:p>
+            <a:pPr algn="ctr" indent="0" marL="0">
+              <a:buNone/>
+            </a:pPr>
+            <a:r>
+              <a:rPr lang="en-US" sz="1000" dirty="0">
                 <a:solidFill>
                   <a:srgbClr val="666666"/>
                 </a:solidFill>
@@ -1843,485 +1962,9 @@
                 <a:ea typeface="Arial" pitchFamily="34" charset="-122"/>
                 <a:cs typeface="Arial" pitchFamily="34" charset="-120"/>
               </a:rPr>
-              <a:t>  No way to track actual usage</a:t>
-            </a:r>
-            <a:endParaRPr lang="en-US" sz="1200" dirty="0"/>
-          </a:p>
-        </p:txBody>
-      </p:sp>
-      <p:sp>
-        <p:nvSpPr>
-          <p:cNvPr id="10" name="Text 8"/>
-          <p:cNvSpPr/>
-          <p:nvPr/>
-        </p:nvSpPr>
-        <p:spPr>
-          <a:xfrm>
-            <a:off x="822960" y="3154680"/>
-            <a:ext cx="3291840" cy="365760"/>
-          </a:xfrm>
-          <a:prstGeom prst="rect">
-            <a:avLst/>
-          </a:prstGeom>
-          <a:noFill/>
-          <a:ln/>
-        </p:spPr>
-        <p:txBody>
-          <a:bodyPr wrap="square" lIns="0" tIns="0" rIns="0" bIns="0" rtlCol="0" anchor="ctr"/>
-          <a:lstStyle/>
-          <a:p>
-            <a:pPr indent="0" marL="0">
-              <a:buNone/>
-            </a:pPr>
-            <a:r>
-              <a:rPr lang="en-US" sz="1200" dirty="0">
-                <a:solidFill>
-                  <a:srgbClr val="666666"/>
-                </a:solidFill>
-                <a:latin typeface="Arial" pitchFamily="34" charset="0"/>
-                <a:ea typeface="Arial" pitchFamily="34" charset="-122"/>
-                <a:cs typeface="Arial" pitchFamily="34" charset="-120"/>
-              </a:rPr>
-              <a:t>  Can't update once printed</a:t>
-            </a:r>
-            <a:endParaRPr lang="en-US" sz="1200" dirty="0"/>
-          </a:p>
-        </p:txBody>
-      </p:sp>
-      <p:sp>
-        <p:nvSpPr>
-          <p:cNvPr id="11" name="Text 9"/>
-          <p:cNvSpPr/>
-          <p:nvPr/>
-        </p:nvSpPr>
-        <p:spPr>
-          <a:xfrm>
-            <a:off x="822960" y="3566160"/>
-            <a:ext cx="3291840" cy="365760"/>
-          </a:xfrm>
-          <a:prstGeom prst="rect">
-            <a:avLst/>
-          </a:prstGeom>
-          <a:noFill/>
-          <a:ln/>
-        </p:spPr>
-        <p:txBody>
-          <a:bodyPr wrap="square" lIns="0" tIns="0" rIns="0" bIns="0" rtlCol="0" anchor="ctr"/>
-          <a:lstStyle/>
-          <a:p>
-            <a:pPr indent="0" marL="0">
-              <a:buNone/>
-            </a:pPr>
-            <a:r>
-              <a:rPr lang="en-US" sz="1200" dirty="0">
-                <a:solidFill>
-                  <a:srgbClr val="666666"/>
-                </a:solidFill>
-                <a:latin typeface="Arial" pitchFamily="34" charset="0"/>
-                <a:ea typeface="Arial" pitchFamily="34" charset="-122"/>
-                <a:cs typeface="Arial" pitchFamily="34" charset="-120"/>
-              </a:rPr>
-              <a:t>  No data for sponsors</a:t>
-            </a:r>
-            <a:endParaRPr lang="en-US" sz="1200" dirty="0"/>
-          </a:p>
-        </p:txBody>
-      </p:sp>
-      <p:sp>
-        <p:nvSpPr>
-          <p:cNvPr id="12" name="Text 10"/>
-          <p:cNvSpPr/>
-          <p:nvPr/>
-        </p:nvSpPr>
-        <p:spPr>
-          <a:xfrm>
-            <a:off x="822960" y="3977640"/>
-            <a:ext cx="3291840" cy="365760"/>
-          </a:xfrm>
-          <a:prstGeom prst="rect">
-            <a:avLst/>
-          </a:prstGeom>
-          <a:noFill/>
-          <a:ln/>
-        </p:spPr>
-        <p:txBody>
-          <a:bodyPr wrap="square" lIns="0" tIns="0" rIns="0" bIns="0" rtlCol="0" anchor="ctr"/>
-          <a:lstStyle/>
-          <a:p>
-            <a:pPr indent="0" marL="0">
-              <a:buNone/>
-            </a:pPr>
-            <a:r>
-              <a:rPr lang="en-US" sz="1200" dirty="0">
-                <a:solidFill>
-                  <a:srgbClr val="666666"/>
-                </a:solidFill>
-                <a:latin typeface="Arial" pitchFamily="34" charset="0"/>
-                <a:ea typeface="Arial" pitchFamily="34" charset="-122"/>
-                <a:cs typeface="Arial" pitchFamily="34" charset="-120"/>
-              </a:rPr>
-              <a:t>  Fraud: easy to photocopy</a:t>
-            </a:r>
-            <a:endParaRPr lang="en-US" sz="1200" dirty="0"/>
-          </a:p>
-        </p:txBody>
-      </p:sp>
-      <p:sp>
-        <p:nvSpPr>
-          <p:cNvPr id="13" name="Shape 11"/>
-          <p:cNvSpPr/>
-          <p:nvPr/>
-        </p:nvSpPr>
-        <p:spPr>
-          <a:xfrm>
-            <a:off x="4754880" y="1280160"/>
-            <a:ext cx="3840480" cy="3474720"/>
-          </a:xfrm>
-          <a:prstGeom prst="rect">
-            <a:avLst/>
-          </a:prstGeom>
-          <a:solidFill>
-            <a:srgbClr val="F0F8F0"/>
-          </a:solidFill>
-          <a:ln/>
-          <a:effectLst>
-            <a:outerShdw sx="100000" sy="100000" kx="0" ky="0" algn="bl" rotWithShape="0" blurRad="101600" dist="38100" dir="8100000">
-              <a:srgbClr val="000000">
-                <a:alpha val="20000"/>
-              </a:srgbClr>
-            </a:outerShdw>
-          </a:effectLst>
-        </p:spPr>
-      </p:sp>
-      <p:sp>
-        <p:nvSpPr>
-          <p:cNvPr id="14" name="Shape 12"/>
-          <p:cNvSpPr/>
-          <p:nvPr/>
-        </p:nvSpPr>
-        <p:spPr>
-          <a:xfrm>
-            <a:off x="4754880" y="1280160"/>
-            <a:ext cx="3840480" cy="54864"/>
-          </a:xfrm>
-          <a:prstGeom prst="rect">
-            <a:avLst/>
-          </a:prstGeom>
-          <a:solidFill>
-            <a:srgbClr val="1A7A1A"/>
-          </a:solidFill>
-          <a:ln/>
-        </p:spPr>
-      </p:sp>
-      <p:sp>
-        <p:nvSpPr>
-          <p:cNvPr id="15" name="Text 13"/>
-          <p:cNvSpPr/>
-          <p:nvPr/>
-        </p:nvSpPr>
-        <p:spPr>
-          <a:xfrm>
-            <a:off x="5029200" y="1463040"/>
-            <a:ext cx="3291840" cy="365760"/>
-          </a:xfrm>
-          <a:prstGeom prst="rect">
-            <a:avLst/>
-          </a:prstGeom>
-          <a:noFill/>
-          <a:ln/>
-        </p:spPr>
-        <p:txBody>
-          <a:bodyPr wrap="square" lIns="0" tIns="0" rIns="0" bIns="0" rtlCol="0" anchor="ctr"/>
-          <a:lstStyle/>
-          <a:p>
-            <a:pPr indent="0" marL="0">
-              <a:buNone/>
-            </a:pPr>
-            <a:r>
-              <a:rPr lang="en-US" sz="1300" b="1" dirty="0">
-                <a:solidFill>
-                  <a:srgbClr val="1A7A1A"/>
-                </a:solidFill>
-                <a:latin typeface="Arial" pitchFamily="34" charset="0"/>
-                <a:ea typeface="Arial" pitchFamily="34" charset="-122"/>
-                <a:cs typeface="Arial" pitchFamily="34" charset="-120"/>
-              </a:rPr>
-              <a:t>PROPOSED: DIGITAL CARD</a:t>
-            </a:r>
-            <a:endParaRPr lang="en-US" sz="1300" dirty="0"/>
-          </a:p>
-        </p:txBody>
-      </p:sp>
-      <p:sp>
-        <p:nvSpPr>
-          <p:cNvPr id="16" name="Text 14"/>
-          <p:cNvSpPr/>
-          <p:nvPr/>
-        </p:nvSpPr>
-        <p:spPr>
-          <a:xfrm>
-            <a:off x="5029200" y="1920240"/>
-            <a:ext cx="3291840" cy="365760"/>
-          </a:xfrm>
-          <a:prstGeom prst="rect">
-            <a:avLst/>
-          </a:prstGeom>
-          <a:noFill/>
-          <a:ln/>
-        </p:spPr>
-        <p:txBody>
-          <a:bodyPr wrap="square" lIns="0" tIns="0" rIns="0" bIns="0" rtlCol="0" anchor="ctr"/>
-          <a:lstStyle/>
-          <a:p>
-            <a:pPr indent="0" marL="0">
-              <a:buNone/>
-            </a:pPr>
-            <a:r>
-              <a:rPr lang="en-US" sz="1200" b="1" dirty="0">
-                <a:solidFill>
-                  <a:srgbClr val="333333"/>
-                </a:solidFill>
-                <a:latin typeface="Arial" pitchFamily="34" charset="0"/>
-                <a:ea typeface="Arial" pitchFamily="34" charset="-122"/>
-                <a:cs typeface="Arial" pitchFamily="34" charset="-120"/>
-              </a:rPr>
-              <a:t>  Zero printing cost for digital</a:t>
-            </a:r>
-            <a:endParaRPr lang="en-US" sz="1200" dirty="0"/>
-          </a:p>
-        </p:txBody>
-      </p:sp>
-      <p:sp>
-        <p:nvSpPr>
-          <p:cNvPr id="17" name="Text 15"/>
-          <p:cNvSpPr/>
-          <p:nvPr/>
-        </p:nvSpPr>
-        <p:spPr>
-          <a:xfrm>
-            <a:off x="5029200" y="2331720"/>
-            <a:ext cx="3291840" cy="365760"/>
-          </a:xfrm>
-          <a:prstGeom prst="rect">
-            <a:avLst/>
-          </a:prstGeom>
-          <a:noFill/>
-          <a:ln/>
-        </p:spPr>
-        <p:txBody>
-          <a:bodyPr wrap="square" lIns="0" tIns="0" rIns="0" bIns="0" rtlCol="0" anchor="ctr"/>
-          <a:lstStyle/>
-          <a:p>
-            <a:pPr indent="0" marL="0">
-              <a:buNone/>
-            </a:pPr>
-            <a:r>
-              <a:rPr lang="en-US" sz="1200" b="1" dirty="0">
-                <a:solidFill>
-                  <a:srgbClr val="333333"/>
-                </a:solidFill>
-                <a:latin typeface="Arial" pitchFamily="34" charset="0"/>
-                <a:ea typeface="Arial" pitchFamily="34" charset="-122"/>
-                <a:cs typeface="Arial" pitchFamily="34" charset="-120"/>
-              </a:rPr>
-              <a:t>  Always in Apple Wallet on their phone</a:t>
-            </a:r>
-            <a:endParaRPr lang="en-US" sz="1200" dirty="0"/>
-          </a:p>
-        </p:txBody>
-      </p:sp>
-      <p:sp>
-        <p:nvSpPr>
-          <p:cNvPr id="18" name="Text 16"/>
-          <p:cNvSpPr/>
-          <p:nvPr/>
-        </p:nvSpPr>
-        <p:spPr>
-          <a:xfrm>
-            <a:off x="5029200" y="2743200"/>
-            <a:ext cx="3291840" cy="365760"/>
-          </a:xfrm>
-          <a:prstGeom prst="rect">
-            <a:avLst/>
-          </a:prstGeom>
-          <a:noFill/>
-          <a:ln/>
-        </p:spPr>
-        <p:txBody>
-          <a:bodyPr wrap="square" lIns="0" tIns="0" rIns="0" bIns="0" rtlCol="0" anchor="ctr"/>
-          <a:lstStyle/>
-          <a:p>
-            <a:pPr indent="0" marL="0">
-              <a:buNone/>
-            </a:pPr>
-            <a:r>
-              <a:rPr lang="en-US" sz="1200" b="1" dirty="0">
-                <a:solidFill>
-                  <a:srgbClr val="333333"/>
-                </a:solidFill>
-                <a:latin typeface="Arial" pitchFamily="34" charset="0"/>
-                <a:ea typeface="Arial" pitchFamily="34" charset="-122"/>
-                <a:cs typeface="Arial" pitchFamily="34" charset="-120"/>
-              </a:rPr>
-              <a:t>  Every scan tracked with analytics</a:t>
-            </a:r>
-            <a:endParaRPr lang="en-US" sz="1200" dirty="0"/>
-          </a:p>
-        </p:txBody>
-      </p:sp>
-      <p:sp>
-        <p:nvSpPr>
-          <p:cNvPr id="19" name="Text 17"/>
-          <p:cNvSpPr/>
-          <p:nvPr/>
-        </p:nvSpPr>
-        <p:spPr>
-          <a:xfrm>
-            <a:off x="5029200" y="3154680"/>
-            <a:ext cx="3291840" cy="365760"/>
-          </a:xfrm>
-          <a:prstGeom prst="rect">
-            <a:avLst/>
-          </a:prstGeom>
-          <a:noFill/>
-          <a:ln/>
-        </p:spPr>
-        <p:txBody>
-          <a:bodyPr wrap="square" lIns="0" tIns="0" rIns="0" bIns="0" rtlCol="0" anchor="ctr"/>
-          <a:lstStyle/>
-          <a:p>
-            <a:pPr indent="0" marL="0">
-              <a:buNone/>
-            </a:pPr>
-            <a:r>
-              <a:rPr lang="en-US" sz="1200" b="1" dirty="0">
-                <a:solidFill>
-                  <a:srgbClr val="333333"/>
-                </a:solidFill>
-                <a:latin typeface="Arial" pitchFamily="34" charset="0"/>
-                <a:ea typeface="Arial" pitchFamily="34" charset="-122"/>
-                <a:cs typeface="Arial" pitchFamily="34" charset="-120"/>
-              </a:rPr>
-              <a:t>  Push new deals anytime mid-season</a:t>
-            </a:r>
-            <a:endParaRPr lang="en-US" sz="1200" dirty="0"/>
-          </a:p>
-        </p:txBody>
-      </p:sp>
-      <p:sp>
-        <p:nvSpPr>
-          <p:cNvPr id="20" name="Text 18"/>
-          <p:cNvSpPr/>
-          <p:nvPr/>
-        </p:nvSpPr>
-        <p:spPr>
-          <a:xfrm>
-            <a:off x="5029200" y="3566160"/>
-            <a:ext cx="3291840" cy="365760"/>
-          </a:xfrm>
-          <a:prstGeom prst="rect">
-            <a:avLst/>
-          </a:prstGeom>
-          <a:noFill/>
-          <a:ln/>
-        </p:spPr>
-        <p:txBody>
-          <a:bodyPr wrap="square" lIns="0" tIns="0" rIns="0" bIns="0" rtlCol="0" anchor="ctr"/>
-          <a:lstStyle/>
-          <a:p>
-            <a:pPr indent="0" marL="0">
-              <a:buNone/>
-            </a:pPr>
-            <a:r>
-              <a:rPr lang="en-US" sz="1200" b="1" dirty="0">
-                <a:solidFill>
-                  <a:srgbClr val="333333"/>
-                </a:solidFill>
-                <a:latin typeface="Arial" pitchFamily="34" charset="0"/>
-                <a:ea typeface="Arial" pitchFamily="34" charset="-122"/>
-                <a:cs typeface="Arial" pitchFamily="34" charset="-120"/>
-              </a:rPr>
-              <a:t>  Sponsor dashboards with real data</a:t>
-            </a:r>
-            <a:endParaRPr lang="en-US" sz="1200" dirty="0"/>
-          </a:p>
-        </p:txBody>
-      </p:sp>
-      <p:sp>
-        <p:nvSpPr>
-          <p:cNvPr id="21" name="Text 19"/>
-          <p:cNvSpPr/>
-          <p:nvPr/>
-        </p:nvSpPr>
-        <p:spPr>
-          <a:xfrm>
-            <a:off x="5029200" y="3977640"/>
-            <a:ext cx="3291840" cy="365760"/>
-          </a:xfrm>
-          <a:prstGeom prst="rect">
-            <a:avLst/>
-          </a:prstGeom>
-          <a:noFill/>
-          <a:ln/>
-        </p:spPr>
-        <p:txBody>
-          <a:bodyPr wrap="square" lIns="0" tIns="0" rIns="0" bIns="0" rtlCol="0" anchor="ctr"/>
-          <a:lstStyle/>
-          <a:p>
-            <a:pPr indent="0" marL="0">
-              <a:buNone/>
-            </a:pPr>
-            <a:r>
-              <a:rPr lang="en-US" sz="1200" b="1" dirty="0">
-                <a:solidFill>
-                  <a:srgbClr val="333333"/>
-                </a:solidFill>
-                <a:latin typeface="Arial" pitchFamily="34" charset="0"/>
-                <a:ea typeface="Arial" pitchFamily="34" charset="-122"/>
-                <a:cs typeface="Arial" pitchFamily="34" charset="-120"/>
-              </a:rPr>
-              <a:t>  Unique IDs + fraud detection built in</a:t>
-            </a:r>
-            <a:endParaRPr lang="en-US" sz="1200" dirty="0"/>
-          </a:p>
-        </p:txBody>
-      </p:sp>
-      <p:sp>
-        <p:nvSpPr>
-          <p:cNvPr id="22" name="Text 20"/>
-          <p:cNvSpPr/>
-          <p:nvPr/>
-        </p:nvSpPr>
-        <p:spPr>
-          <a:xfrm>
-            <a:off x="731520" y="4572000"/>
-            <a:ext cx="7680960" cy="365760"/>
-          </a:xfrm>
-          <a:prstGeom prst="rect">
-            <a:avLst/>
-          </a:prstGeom>
-          <a:noFill/>
-          <a:ln/>
-        </p:spPr>
-        <p:txBody>
-          <a:bodyPr wrap="square" lIns="0" tIns="0" rIns="0" bIns="0" rtlCol="0" anchor="ctr"/>
-          <a:lstStyle/>
-          <a:p>
-            <a:pPr indent="0" marL="0">
-              <a:buNone/>
-            </a:pPr>
-            <a:r>
-              <a:rPr lang="en-US" sz="1200" i="1" dirty="0">
-                <a:solidFill>
-                  <a:srgbClr val="888888"/>
-                </a:solidFill>
-                <a:latin typeface="Arial" pitchFamily="34" charset="0"/>
-                <a:ea typeface="Arial" pitchFamily="34" charset="-122"/>
-                <a:cs typeface="Arial" pitchFamily="34" charset="-120"/>
-              </a:rPr>
-              <a:t>Physical cards are still available. Each has a unique QR code linking to the digital version.</a:t>
-            </a:r>
-            <a:endParaRPr lang="en-US" sz="1200" dirty="0"/>
+              <a:t>to digital.</a:t>
+            </a:r>
+            <a:endParaRPr lang="en-US" sz="1000" dirty="0"/>
           </a:p>
         </p:txBody>
       </p:sp>
@@ -3211,7 +2854,7 @@
                 <a:ea typeface="Arial" pitchFamily="34" charset="-122"/>
                 <a:cs typeface="Arial" pitchFamily="34" charset="-120"/>
               </a:rPr>
-              <a:t>Card printing (existing budget)</a:t>
+              <a:t>Card printing</a:t>
             </a:r>
             <a:endParaRPr lang="en-US" sz="1200" dirty="0"/>
           </a:p>
@@ -3250,7 +2893,7 @@
                 <a:ea typeface="Arial" pitchFamily="34" charset="-122"/>
                 <a:cs typeface="Arial" pitchFamily="34" charset="-120"/>
               </a:rPr>
-              <a:t>$0 add'l</a:t>
+              <a:t>Existing budget</a:t>
             </a:r>
             <a:endParaRPr lang="en-US" sz="1200" dirty="0"/>
           </a:p>
@@ -3429,45 +3072,6 @@
               <a:t>~$160-220</a:t>
             </a:r>
             <a:endParaRPr lang="en-US" sz="1300" dirty="0"/>
-          </a:p>
-        </p:txBody>
-      </p:sp>
-      <p:sp>
-        <p:nvSpPr>
-          <p:cNvPr id="33" name="Text 30"/>
-          <p:cNvSpPr/>
-          <p:nvPr/>
-        </p:nvSpPr>
-        <p:spPr>
-          <a:xfrm>
-            <a:off x="731520" y="4114800"/>
-            <a:ext cx="7680960" cy="365760"/>
-          </a:xfrm>
-          <a:prstGeom prst="rect">
-            <a:avLst/>
-          </a:prstGeom>
-          <a:noFill/>
-          <a:ln/>
-        </p:spPr>
-        <p:txBody>
-          <a:bodyPr wrap="square" lIns="0" tIns="0" rIns="0" bIns="0" rtlCol="0" anchor="ctr"/>
-          <a:lstStyle/>
-          <a:p>
-            <a:pPr indent="0" marL="0">
-              <a:buNone/>
-            </a:pPr>
-            <a:r>
-              <a:rPr lang="en-US" sz="1200" i="1" dirty="0">
-                <a:solidFill>
-                  <a:srgbClr val="D4B96A"/>
-                </a:solidFill>
-                <a:latin typeface="Arial" pitchFamily="34" charset="0"/>
-                <a:ea typeface="Arial" pitchFamily="34" charset="-122"/>
-                <a:cs typeface="Arial" pitchFamily="34" charset="-120"/>
-              </a:rPr>
-              <a:t>Net savings vs. physical-only: eliminates reprinting costs when sponsors change mid-season.</a:t>
-            </a:r>
-            <a:endParaRPr lang="en-US" sz="1200" dirty="0"/>
           </a:p>
         </p:txBody>
       </p:sp>
@@ -3556,7 +3160,7 @@
                 <a:ea typeface="Arial Black" pitchFamily="34" charset="-122"/>
                 <a:cs typeface="Arial Black" pitchFamily="34" charset="-120"/>
               </a:rPr>
-              <a:t>FRAUD PREVENTION AND SECURITY</a:t>
+              <a:t>FRAUD PREVENTION</a:t>
             </a:r>
             <a:endParaRPr lang="en-US" sz="2400" dirty="0"/>
           </a:p>
@@ -3570,8 +3174,8 @@
         </p:nvSpPr>
         <p:spPr>
           <a:xfrm>
-            <a:off x="731520" y="1188720"/>
-            <a:ext cx="7680960" cy="640080"/>
+            <a:off x="548640" y="1188720"/>
+            <a:ext cx="4572000" cy="438912"/>
           </a:xfrm>
           <a:prstGeom prst="rect">
             <a:avLst/>
@@ -3580,13 +3184,6 @@
             <a:srgbClr val="F5F0E6"/>
           </a:solidFill>
           <a:ln/>
-          <a:effectLst>
-            <a:outerShdw sx="100000" sy="100000" kx="0" ky="0" algn="bl" rotWithShape="0" blurRad="101600" dist="38100" dir="8100000">
-              <a:srgbClr val="000000">
-                <a:alpha val="20000"/>
-              </a:srgbClr>
-            </a:outerShdw>
-          </a:effectLst>
         </p:spPr>
       </p:sp>
       <p:sp>
@@ -3597,8 +3194,8 @@
         </p:nvSpPr>
         <p:spPr>
           <a:xfrm>
-            <a:off x="731520" y="1188720"/>
-            <a:ext cx="54864" cy="640080"/>
+            <a:off x="548640" y="1188720"/>
+            <a:ext cx="54864" cy="438912"/>
           </a:xfrm>
           <a:prstGeom prst="rect">
             <a:avLst/>
@@ -3617,8 +3214,8 @@
         </p:nvSpPr>
         <p:spPr>
           <a:xfrm>
-            <a:off x="1005840" y="1188720"/>
-            <a:ext cx="2011680" cy="640080"/>
+            <a:off x="822960" y="1188720"/>
+            <a:ext cx="4114800" cy="438912"/>
           </a:xfrm>
           <a:prstGeom prst="rect">
             <a:avLst/>
@@ -3634,7 +3231,7 @@
               <a:buNone/>
             </a:pPr>
             <a:r>
-              <a:rPr lang="en-US" sz="1300" b="1" dirty="0">
+              <a:rPr lang="en-US" sz="1100" dirty="0">
                 <a:solidFill>
                   <a:srgbClr val="002D62"/>
                 </a:solidFill>
@@ -3642,22 +3239,62 @@
                 <a:ea typeface="Arial" pitchFamily="34" charset="-122"/>
                 <a:cs typeface="Arial" pitchFamily="34" charset="-120"/>
               </a:rPr>
-              <a:t>Unique Card IDs</a:t>
-            </a:r>
-            <a:endParaRPr lang="en-US" sz="1300" dirty="0"/>
-          </a:p>
-        </p:txBody>
-      </p:sp>
-      <p:sp>
-        <p:nvSpPr>
-          <p:cNvPr id="7" name="Text 5"/>
-          <p:cNvSpPr/>
-          <p:nvPr/>
-        </p:nvSpPr>
-        <p:spPr>
-          <a:xfrm>
-            <a:off x="3017520" y="1188720"/>
-            <a:ext cx="5212080" cy="640080"/>
+              <a:t>Unique Card IDs — no two cards alike</a:t>
+            </a:r>
+            <a:endParaRPr lang="en-US" sz="1100" dirty="0"/>
+          </a:p>
+        </p:txBody>
+      </p:sp>
+      <p:sp>
+        <p:nvSpPr>
+          <p:cNvPr id="7" name="Shape 5"/>
+          <p:cNvSpPr/>
+          <p:nvPr/>
+        </p:nvSpPr>
+        <p:spPr>
+          <a:xfrm>
+            <a:off x="548640" y="1691640"/>
+            <a:ext cx="4572000" cy="438912"/>
+          </a:xfrm>
+          <a:prstGeom prst="rect">
+            <a:avLst/>
+          </a:prstGeom>
+          <a:solidFill>
+            <a:srgbClr val="FFFFFF"/>
+          </a:solidFill>
+          <a:ln/>
+        </p:spPr>
+      </p:sp>
+      <p:sp>
+        <p:nvSpPr>
+          <p:cNvPr id="8" name="Shape 6"/>
+          <p:cNvSpPr/>
+          <p:nvPr/>
+        </p:nvSpPr>
+        <p:spPr>
+          <a:xfrm>
+            <a:off x="548640" y="1691640"/>
+            <a:ext cx="54864" cy="438912"/>
+          </a:xfrm>
+          <a:prstGeom prst="rect">
+            <a:avLst/>
+          </a:prstGeom>
+          <a:solidFill>
+            <a:srgbClr val="C5A55A"/>
+          </a:solidFill>
+          <a:ln/>
+        </p:spPr>
+      </p:sp>
+      <p:sp>
+        <p:nvSpPr>
+          <p:cNvPr id="9" name="Text 7"/>
+          <p:cNvSpPr/>
+          <p:nvPr/>
+        </p:nvSpPr>
+        <p:spPr>
+          <a:xfrm>
+            <a:off x="822960" y="1691640"/>
+            <a:ext cx="4114800" cy="438912"/>
           </a:xfrm>
           <a:prstGeom prst="rect">
             <a:avLst/>
@@ -3675,13 +3312,13 @@
             <a:r>
               <a:rPr lang="en-US" sz="1100" dirty="0">
                 <a:solidFill>
-                  <a:srgbClr val="555555"/>
-                </a:solidFill>
-                <a:latin typeface="Arial" pitchFamily="34" charset="0"/>
-                <a:ea typeface="Arial" pitchFamily="34" charset="-122"/>
-                <a:cs typeface="Arial" pitchFamily="34" charset="-120"/>
-              </a:rPr>
-              <a:t>Each card has a cryptographically generated ID — no two cards are alike. Screenshots show a static image that cashiers are trained to flag.</a:t>
+                  <a:srgbClr val="002D62"/>
+                </a:solidFill>
+                <a:latin typeface="Arial" pitchFamily="34" charset="0"/>
+                <a:ea typeface="Arial" pitchFamily="34" charset="-122"/>
+                <a:cs typeface="Arial" pitchFamily="34" charset="-120"/>
+              </a:rPr>
+              <a:t>Cardholder's name shown on scan — cashier verifies</a:t>
             </a:r>
             <a:endParaRPr lang="en-US" sz="1100" dirty="0"/>
           </a:p>
@@ -3689,14 +3326,14 @@
       </p:sp>
       <p:sp>
         <p:nvSpPr>
-          <p:cNvPr id="8" name="Shape 6"/>
-          <p:cNvSpPr/>
-          <p:nvPr/>
-        </p:nvSpPr>
-        <p:spPr>
-          <a:xfrm>
-            <a:off x="731520" y="1938528"/>
-            <a:ext cx="7680960" cy="640080"/>
+          <p:cNvPr id="10" name="Shape 8"/>
+          <p:cNvSpPr/>
+          <p:nvPr/>
+        </p:nvSpPr>
+        <p:spPr>
+          <a:xfrm>
+            <a:off x="548640" y="2194560"/>
+            <a:ext cx="4572000" cy="438912"/>
           </a:xfrm>
           <a:prstGeom prst="rect">
             <a:avLst/>
@@ -3705,25 +3342,18 @@
             <a:srgbClr val="F5F0E6"/>
           </a:solidFill>
           <a:ln/>
-          <a:effectLst>
-            <a:outerShdw sx="100000" sy="100000" kx="0" ky="0" algn="bl" rotWithShape="0" blurRad="101600" dist="38100" dir="8100000">
-              <a:srgbClr val="000000">
-                <a:alpha val="20000"/>
-              </a:srgbClr>
-            </a:outerShdw>
-          </a:effectLst>
-        </p:spPr>
-      </p:sp>
-      <p:sp>
-        <p:nvSpPr>
-          <p:cNvPr id="9" name="Shape 7"/>
-          <p:cNvSpPr/>
-          <p:nvPr/>
-        </p:nvSpPr>
-        <p:spPr>
-          <a:xfrm>
-            <a:off x="731520" y="1938528"/>
-            <a:ext cx="54864" cy="640080"/>
+        </p:spPr>
+      </p:sp>
+      <p:sp>
+        <p:nvSpPr>
+          <p:cNvPr id="11" name="Shape 9"/>
+          <p:cNvSpPr/>
+          <p:nvPr/>
+        </p:nvSpPr>
+        <p:spPr>
+          <a:xfrm>
+            <a:off x="548640" y="2194560"/>
+            <a:ext cx="54864" cy="438912"/>
           </a:xfrm>
           <a:prstGeom prst="rect">
             <a:avLst/>
@@ -3736,14 +3366,14 @@
       </p:sp>
       <p:sp>
         <p:nvSpPr>
-          <p:cNvPr id="10" name="Text 8"/>
-          <p:cNvSpPr/>
-          <p:nvPr/>
-        </p:nvSpPr>
-        <p:spPr>
-          <a:xfrm>
-            <a:off x="1005840" y="1938528"/>
-            <a:ext cx="2011680" cy="640080"/>
+          <p:cNvPr id="12" name="Text 10"/>
+          <p:cNvSpPr/>
+          <p:nvPr/>
+        </p:nvSpPr>
+        <p:spPr>
+          <a:xfrm>
+            <a:off x="822960" y="2194560"/>
+            <a:ext cx="4114800" cy="438912"/>
           </a:xfrm>
           <a:prstGeom prst="rect">
             <a:avLst/>
@@ -3759,7 +3389,7 @@
               <a:buNone/>
             </a:pPr>
             <a:r>
-              <a:rPr lang="en-US" sz="1300" b="1" dirty="0">
+              <a:rPr lang="en-US" sz="1100" dirty="0">
                 <a:solidFill>
                   <a:srgbClr val="002D62"/>
                 </a:solidFill>
@@ -3767,22 +3397,62 @@
                 <a:ea typeface="Arial" pitchFamily="34" charset="-122"/>
                 <a:cs typeface="Arial" pitchFamily="34" charset="-120"/>
               </a:rPr>
-              <a:t>Name Verification</a:t>
-            </a:r>
-            <a:endParaRPr lang="en-US" sz="1300" dirty="0"/>
-          </a:p>
-        </p:txBody>
-      </p:sp>
-      <p:sp>
-        <p:nvSpPr>
-          <p:cNvPr id="11" name="Text 9"/>
-          <p:cNvSpPr/>
-          <p:nvPr/>
-        </p:nvSpPr>
-        <p:spPr>
-          <a:xfrm>
-            <a:off x="3017520" y="1938528"/>
-            <a:ext cx="5212080" cy="640080"/>
+              <a:t>Rate limiting — flags 5+ scans in 24hrs</a:t>
+            </a:r>
+            <a:endParaRPr lang="en-US" sz="1100" dirty="0"/>
+          </a:p>
+        </p:txBody>
+      </p:sp>
+      <p:sp>
+        <p:nvSpPr>
+          <p:cNvPr id="13" name="Shape 11"/>
+          <p:cNvSpPr/>
+          <p:nvPr/>
+        </p:nvSpPr>
+        <p:spPr>
+          <a:xfrm>
+            <a:off x="548640" y="2697480"/>
+            <a:ext cx="4572000" cy="438912"/>
+          </a:xfrm>
+          <a:prstGeom prst="rect">
+            <a:avLst/>
+          </a:prstGeom>
+          <a:solidFill>
+            <a:srgbClr val="FFFFFF"/>
+          </a:solidFill>
+          <a:ln/>
+        </p:spPr>
+      </p:sp>
+      <p:sp>
+        <p:nvSpPr>
+          <p:cNvPr id="14" name="Shape 12"/>
+          <p:cNvSpPr/>
+          <p:nvPr/>
+        </p:nvSpPr>
+        <p:spPr>
+          <a:xfrm>
+            <a:off x="548640" y="2697480"/>
+            <a:ext cx="54864" cy="438912"/>
+          </a:xfrm>
+          <a:prstGeom prst="rect">
+            <a:avLst/>
+          </a:prstGeom>
+          <a:solidFill>
+            <a:srgbClr val="C5A55A"/>
+          </a:solidFill>
+          <a:ln/>
+        </p:spPr>
+      </p:sp>
+      <p:sp>
+        <p:nvSpPr>
+          <p:cNvPr id="15" name="Text 13"/>
+          <p:cNvSpPr/>
+          <p:nvPr/>
+        </p:nvSpPr>
+        <p:spPr>
+          <a:xfrm>
+            <a:off x="822960" y="2697480"/>
+            <a:ext cx="4114800" cy="438912"/>
           </a:xfrm>
           <a:prstGeom prst="rect">
             <a:avLst/>
@@ -3800,13 +3470,13 @@
             <a:r>
               <a:rPr lang="en-US" sz="1100" dirty="0">
                 <a:solidFill>
-                  <a:srgbClr val="555555"/>
-                </a:solidFill>
-                <a:latin typeface="Arial" pitchFamily="34" charset="0"/>
-                <a:ea typeface="Arial" pitchFamily="34" charset="-122"/>
-                <a:cs typeface="Arial" pitchFamily="34" charset="-120"/>
-              </a:rPr>
-              <a:t>When scanned, the verification screen shows the cardholder's name in large text. Cashiers can ask "Are you John?" to confirm identity.</a:t>
+                  <a:srgbClr val="002D62"/>
+                </a:solidFill>
+                <a:latin typeface="Arial" pitchFamily="34" charset="0"/>
+                <a:ea typeface="Arial" pitchFamily="34" charset="-122"/>
+                <a:cs typeface="Arial" pitchFamily="34" charset="-120"/>
+              </a:rPr>
+              <a:t>Rapid scan detection — warns if just used elsewhere</a:t>
             </a:r>
             <a:endParaRPr lang="en-US" sz="1100" dirty="0"/>
           </a:p>
@@ -3814,14 +3484,14 @@
       </p:sp>
       <p:sp>
         <p:nvSpPr>
-          <p:cNvPr id="12" name="Shape 10"/>
-          <p:cNvSpPr/>
-          <p:nvPr/>
-        </p:nvSpPr>
-        <p:spPr>
-          <a:xfrm>
-            <a:off x="731520" y="2688336"/>
-            <a:ext cx="7680960" cy="640080"/>
+          <p:cNvPr id="16" name="Shape 14"/>
+          <p:cNvSpPr/>
+          <p:nvPr/>
+        </p:nvSpPr>
+        <p:spPr>
+          <a:xfrm>
+            <a:off x="548640" y="3200400"/>
+            <a:ext cx="4572000" cy="438912"/>
           </a:xfrm>
           <a:prstGeom prst="rect">
             <a:avLst/>
@@ -3830,25 +3500,18 @@
             <a:srgbClr val="F5F0E6"/>
           </a:solidFill>
           <a:ln/>
-          <a:effectLst>
-            <a:outerShdw sx="100000" sy="100000" kx="0" ky="0" algn="bl" rotWithShape="0" blurRad="101600" dist="38100" dir="8100000">
-              <a:srgbClr val="000000">
-                <a:alpha val="20000"/>
-              </a:srgbClr>
-            </a:outerShdw>
-          </a:effectLst>
-        </p:spPr>
-      </p:sp>
-      <p:sp>
-        <p:nvSpPr>
-          <p:cNvPr id="13" name="Shape 11"/>
-          <p:cNvSpPr/>
-          <p:nvPr/>
-        </p:nvSpPr>
-        <p:spPr>
-          <a:xfrm>
-            <a:off x="731520" y="2688336"/>
-            <a:ext cx="54864" cy="640080"/>
+        </p:spPr>
+      </p:sp>
+      <p:sp>
+        <p:nvSpPr>
+          <p:cNvPr id="17" name="Shape 15"/>
+          <p:cNvSpPr/>
+          <p:nvPr/>
+        </p:nvSpPr>
+        <p:spPr>
+          <a:xfrm>
+            <a:off x="548640" y="3200400"/>
+            <a:ext cx="54864" cy="438912"/>
           </a:xfrm>
           <a:prstGeom prst="rect">
             <a:avLst/>
@@ -3861,14 +3524,14 @@
       </p:sp>
       <p:sp>
         <p:nvSpPr>
-          <p:cNvPr id="14" name="Text 12"/>
-          <p:cNvSpPr/>
-          <p:nvPr/>
-        </p:nvSpPr>
-        <p:spPr>
-          <a:xfrm>
-            <a:off x="1005840" y="2688336"/>
-            <a:ext cx="2011680" cy="640080"/>
+          <p:cNvPr id="18" name="Text 16"/>
+          <p:cNvSpPr/>
+          <p:nvPr/>
+        </p:nvSpPr>
+        <p:spPr>
+          <a:xfrm>
+            <a:off x="822960" y="3200400"/>
+            <a:ext cx="4114800" cy="438912"/>
           </a:xfrm>
           <a:prstGeom prst="rect">
             <a:avLst/>
@@ -3884,7 +3547,7 @@
               <a:buNone/>
             </a:pPr>
             <a:r>
-              <a:rPr lang="en-US" sz="1300" b="1" dirty="0">
+              <a:rPr lang="en-US" sz="1100" dirty="0">
                 <a:solidFill>
                   <a:srgbClr val="002D62"/>
                 </a:solidFill>
@@ -3892,22 +3555,146 @@
                 <a:ea typeface="Arial" pitchFamily="34" charset="-122"/>
                 <a:cs typeface="Arial" pitchFamily="34" charset="-120"/>
               </a:rPr>
-              <a:t>Rate Limiting</a:t>
-            </a:r>
-            <a:endParaRPr lang="en-US" sz="1300" dirty="0"/>
-          </a:p>
-        </p:txBody>
-      </p:sp>
-      <p:sp>
-        <p:nvSpPr>
-          <p:cNvPr id="15" name="Text 13"/>
-          <p:cNvSpPr/>
-          <p:nvPr/>
-        </p:nvSpPr>
-        <p:spPr>
-          <a:xfrm>
-            <a:off x="3017520" y="2688336"/>
-            <a:ext cx="5212080" cy="640080"/>
+              <a:t>Instant deactivation from admin dashboard</a:t>
+            </a:r>
+            <a:endParaRPr lang="en-US" sz="1100" dirty="0"/>
+          </a:p>
+        </p:txBody>
+      </p:sp>
+      <p:sp>
+        <p:nvSpPr>
+          <p:cNvPr id="19" name="Text 17"/>
+          <p:cNvSpPr/>
+          <p:nvPr/>
+        </p:nvSpPr>
+        <p:spPr>
+          <a:xfrm>
+            <a:off x="5303520" y="1097280"/>
+            <a:ext cx="1828800" cy="228600"/>
+          </a:xfrm>
+          <a:prstGeom prst="rect">
+            <a:avLst/>
+          </a:prstGeom>
+          <a:noFill/>
+          <a:ln/>
+        </p:spPr>
+        <p:txBody>
+          <a:bodyPr wrap="square" lIns="0" tIns="0" rIns="0" bIns="0" rtlCol="0" anchor="ctr"/>
+          <a:lstStyle/>
+          <a:p>
+            <a:pPr algn="ctr" indent="0" marL="0">
+              <a:buNone/>
+            </a:pPr>
+            <a:r>
+              <a:rPr lang="en-US" sz="900" b="1" dirty="0">
+                <a:solidFill>
+                  <a:srgbClr val="1A7A1A"/>
+                </a:solidFill>
+                <a:latin typeface="Arial" pitchFamily="34" charset="0"/>
+                <a:ea typeface="Arial" pitchFamily="34" charset="-122"/>
+                <a:cs typeface="Arial" pitchFamily="34" charset="-120"/>
+              </a:rPr>
+              <a:t>Valid Scan</a:t>
+            </a:r>
+            <a:endParaRPr lang="en-US" sz="900" dirty="0"/>
+          </a:p>
+        </p:txBody>
+      </p:sp>
+      <p:pic>
+        <p:nvPicPr>
+          <p:cNvPr id="20" name="Image 0" descr="preencoded.png">    </p:cNvPr>
+          <p:cNvPicPr>
+            <a:picLocks noChangeAspect="1"/>
+          </p:cNvPicPr>
+          <p:nvPr/>
+        </p:nvPicPr>
+        <p:blipFill>
+          <a:blip r:embed="rId1"/>
+          <a:srcRect l="0" r="0" t="0" b="0"/>
+          <a:stretch/>
+        </p:blipFill>
+        <p:spPr>
+          <a:xfrm>
+            <a:off x="5303520" y="1325880"/>
+            <a:ext cx="1737360" cy="2258568"/>
+          </a:xfrm>
+          <a:prstGeom prst="rect">
+            <a:avLst/>
+          </a:prstGeom>
+        </p:spPr>
+      </p:pic>
+      <p:sp>
+        <p:nvSpPr>
+          <p:cNvPr id="21" name="Text 18"/>
+          <p:cNvSpPr/>
+          <p:nvPr/>
+        </p:nvSpPr>
+        <p:spPr>
+          <a:xfrm>
+            <a:off x="7223760" y="1097280"/>
+            <a:ext cx="1828800" cy="228600"/>
+          </a:xfrm>
+          <a:prstGeom prst="rect">
+            <a:avLst/>
+          </a:prstGeom>
+          <a:noFill/>
+          <a:ln/>
+        </p:spPr>
+        <p:txBody>
+          <a:bodyPr wrap="square" lIns="0" tIns="0" rIns="0" bIns="0" rtlCol="0" anchor="ctr"/>
+          <a:lstStyle/>
+          <a:p>
+            <a:pPr algn="ctr" indent="0" marL="0">
+              <a:buNone/>
+            </a:pPr>
+            <a:r>
+              <a:rPr lang="en-US" sz="900" b="1" dirty="0">
+                <a:solidFill>
+                  <a:srgbClr val="CC8800"/>
+                </a:solidFill>
+                <a:latin typeface="Arial" pitchFamily="34" charset="0"/>
+                <a:ea typeface="Arial" pitchFamily="34" charset="-122"/>
+                <a:cs typeface="Arial" pitchFamily="34" charset="-120"/>
+              </a:rPr>
+              <a:t>Fraud Warning</a:t>
+            </a:r>
+            <a:endParaRPr lang="en-US" sz="900" dirty="0"/>
+          </a:p>
+        </p:txBody>
+      </p:sp>
+      <p:pic>
+        <p:nvPicPr>
+          <p:cNvPr id="22" name="Image 1" descr="preencoded.png">    </p:cNvPr>
+          <p:cNvPicPr>
+            <a:picLocks noChangeAspect="1"/>
+          </p:cNvPicPr>
+          <p:nvPr/>
+        </p:nvPicPr>
+        <p:blipFill>
+          <a:blip r:embed="rId2"/>
+          <a:srcRect l="0" r="0" t="0" b="0"/>
+          <a:stretch/>
+        </p:blipFill>
+        <p:spPr>
+          <a:xfrm>
+            <a:off x="7223760" y="1325880"/>
+            <a:ext cx="1737360" cy="1737360"/>
+          </a:xfrm>
+          <a:prstGeom prst="rect">
+            <a:avLst/>
+          </a:prstGeom>
+        </p:spPr>
+      </p:pic>
+      <p:sp>
+        <p:nvSpPr>
+          <p:cNvPr id="23" name="Text 19"/>
+          <p:cNvSpPr/>
+          <p:nvPr/>
+        </p:nvSpPr>
+        <p:spPr>
+          <a:xfrm>
+            <a:off x="548640" y="4389120"/>
+            <a:ext cx="8046720" cy="365760"/>
           </a:xfrm>
           <a:prstGeom prst="rect">
             <a:avLst/>
@@ -3923,265 +3710,15 @@
               <a:buNone/>
             </a:pPr>
             <a:r>
-              <a:rPr lang="en-US" sz="1100" dirty="0">
-                <a:solidFill>
-                  <a:srgbClr val="555555"/>
-                </a:solidFill>
-                <a:latin typeface="Arial" pitchFamily="34" charset="0"/>
-                <a:ea typeface="Arial" pitchFamily="34" charset="-122"/>
-                <a:cs typeface="Arial" pitchFamily="34" charset="-120"/>
-              </a:rPr>
-              <a:t>Cards scanned more than 5 times in 24 hours are automatically flagged with a yellow warning. Alerts the cashier to verify identity.</a:t>
-            </a:r>
-            <a:endParaRPr lang="en-US" sz="1100" dirty="0"/>
-          </a:p>
-        </p:txBody>
-      </p:sp>
-      <p:sp>
-        <p:nvSpPr>
-          <p:cNvPr id="16" name="Shape 14"/>
-          <p:cNvSpPr/>
-          <p:nvPr/>
-        </p:nvSpPr>
-        <p:spPr>
-          <a:xfrm>
-            <a:off x="731520" y="3438144"/>
-            <a:ext cx="7680960" cy="640080"/>
-          </a:xfrm>
-          <a:prstGeom prst="rect">
-            <a:avLst/>
-          </a:prstGeom>
-          <a:solidFill>
-            <a:srgbClr val="F5F0E6"/>
-          </a:solidFill>
-          <a:ln/>
-          <a:effectLst>
-            <a:outerShdw sx="100000" sy="100000" kx="0" ky="0" algn="bl" rotWithShape="0" blurRad="101600" dist="38100" dir="8100000">
-              <a:srgbClr val="000000">
-                <a:alpha val="20000"/>
-              </a:srgbClr>
-            </a:outerShdw>
-          </a:effectLst>
-        </p:spPr>
-      </p:sp>
-      <p:sp>
-        <p:nvSpPr>
-          <p:cNvPr id="17" name="Shape 15"/>
-          <p:cNvSpPr/>
-          <p:nvPr/>
-        </p:nvSpPr>
-        <p:spPr>
-          <a:xfrm>
-            <a:off x="731520" y="3438144"/>
-            <a:ext cx="54864" cy="640080"/>
-          </a:xfrm>
-          <a:prstGeom prst="rect">
-            <a:avLst/>
-          </a:prstGeom>
-          <a:solidFill>
-            <a:srgbClr val="C5A55A"/>
-          </a:solidFill>
-          <a:ln/>
-        </p:spPr>
-      </p:sp>
-      <p:sp>
-        <p:nvSpPr>
-          <p:cNvPr id="18" name="Text 16"/>
-          <p:cNvSpPr/>
-          <p:nvPr/>
-        </p:nvSpPr>
-        <p:spPr>
-          <a:xfrm>
-            <a:off x="1005840" y="3438144"/>
-            <a:ext cx="2011680" cy="640080"/>
-          </a:xfrm>
-          <a:prstGeom prst="rect">
-            <a:avLst/>
-          </a:prstGeom>
-          <a:noFill/>
-          <a:ln/>
-        </p:spPr>
-        <p:txBody>
-          <a:bodyPr wrap="square" lIns="0" tIns="0" rIns="0" bIns="0" rtlCol="0" anchor="ctr"/>
-          <a:lstStyle/>
-          <a:p>
-            <a:pPr indent="0" marL="0">
-              <a:buNone/>
-            </a:pPr>
-            <a:r>
-              <a:rPr lang="en-US" sz="1300" b="1" dirty="0">
-                <a:solidFill>
-                  <a:srgbClr val="002D62"/>
-                </a:solidFill>
-                <a:latin typeface="Arial" pitchFamily="34" charset="0"/>
-                <a:ea typeface="Arial" pitchFamily="34" charset="-122"/>
-                <a:cs typeface="Arial" pitchFamily="34" charset="-120"/>
-              </a:rPr>
-              <a:t>Rapid Scan Detection</a:t>
-            </a:r>
-            <a:endParaRPr lang="en-US" sz="1300" dirty="0"/>
-          </a:p>
-        </p:txBody>
-      </p:sp>
-      <p:sp>
-        <p:nvSpPr>
-          <p:cNvPr id="19" name="Text 17"/>
-          <p:cNvSpPr/>
-          <p:nvPr/>
-        </p:nvSpPr>
-        <p:spPr>
-          <a:xfrm>
-            <a:off x="3017520" y="3438144"/>
-            <a:ext cx="5212080" cy="640080"/>
-          </a:xfrm>
-          <a:prstGeom prst="rect">
-            <a:avLst/>
-          </a:prstGeom>
-          <a:noFill/>
-          <a:ln/>
-        </p:spPr>
-        <p:txBody>
-          <a:bodyPr wrap="square" lIns="0" tIns="0" rIns="0" bIns="0" rtlCol="0" anchor="ctr"/>
-          <a:lstStyle/>
-          <a:p>
-            <a:pPr indent="0" marL="0">
-              <a:buNone/>
-            </a:pPr>
-            <a:r>
-              <a:rPr lang="en-US" sz="1100" dirty="0">
-                <a:solidFill>
-                  <a:srgbClr val="555555"/>
-                </a:solidFill>
-                <a:latin typeface="Arial" pitchFamily="34" charset="0"/>
-                <a:ea typeface="Arial" pitchFamily="34" charset="-122"/>
-                <a:cs typeface="Arial" pitchFamily="34" charset="-120"/>
-              </a:rPr>
-              <a:t>If the same card was scanned minutes ago at a different business, a warning shows with the time and location of the last scan.</a:t>
-            </a:r>
-            <a:endParaRPr lang="en-US" sz="1100" dirty="0"/>
-          </a:p>
-        </p:txBody>
-      </p:sp>
-      <p:sp>
-        <p:nvSpPr>
-          <p:cNvPr id="20" name="Shape 18"/>
-          <p:cNvSpPr/>
-          <p:nvPr/>
-        </p:nvSpPr>
-        <p:spPr>
-          <a:xfrm>
-            <a:off x="731520" y="4187952"/>
-            <a:ext cx="7680960" cy="640080"/>
-          </a:xfrm>
-          <a:prstGeom prst="rect">
-            <a:avLst/>
-          </a:prstGeom>
-          <a:solidFill>
-            <a:srgbClr val="F5F0E6"/>
-          </a:solidFill>
-          <a:ln/>
-          <a:effectLst>
-            <a:outerShdw sx="100000" sy="100000" kx="0" ky="0" algn="bl" rotWithShape="0" blurRad="101600" dist="38100" dir="8100000">
-              <a:srgbClr val="000000">
-                <a:alpha val="20000"/>
-              </a:srgbClr>
-            </a:outerShdw>
-          </a:effectLst>
-        </p:spPr>
-      </p:sp>
-      <p:sp>
-        <p:nvSpPr>
-          <p:cNvPr id="21" name="Shape 19"/>
-          <p:cNvSpPr/>
-          <p:nvPr/>
-        </p:nvSpPr>
-        <p:spPr>
-          <a:xfrm>
-            <a:off x="731520" y="4187952"/>
-            <a:ext cx="54864" cy="640080"/>
-          </a:xfrm>
-          <a:prstGeom prst="rect">
-            <a:avLst/>
-          </a:prstGeom>
-          <a:solidFill>
-            <a:srgbClr val="C5A55A"/>
-          </a:solidFill>
-          <a:ln/>
-        </p:spPr>
-      </p:sp>
-      <p:sp>
-        <p:nvSpPr>
-          <p:cNvPr id="22" name="Text 20"/>
-          <p:cNvSpPr/>
-          <p:nvPr/>
-        </p:nvSpPr>
-        <p:spPr>
-          <a:xfrm>
-            <a:off x="1005840" y="4187952"/>
-            <a:ext cx="2011680" cy="640080"/>
-          </a:xfrm>
-          <a:prstGeom prst="rect">
-            <a:avLst/>
-          </a:prstGeom>
-          <a:noFill/>
-          <a:ln/>
-        </p:spPr>
-        <p:txBody>
-          <a:bodyPr wrap="square" lIns="0" tIns="0" rIns="0" bIns="0" rtlCol="0" anchor="ctr"/>
-          <a:lstStyle/>
-          <a:p>
-            <a:pPr indent="0" marL="0">
-              <a:buNone/>
-            </a:pPr>
-            <a:r>
-              <a:rPr lang="en-US" sz="1300" b="1" dirty="0">
-                <a:solidFill>
-                  <a:srgbClr val="002D62"/>
-                </a:solidFill>
-                <a:latin typeface="Arial" pitchFamily="34" charset="0"/>
-                <a:ea typeface="Arial" pitchFamily="34" charset="-122"/>
-                <a:cs typeface="Arial" pitchFamily="34" charset="-120"/>
-              </a:rPr>
-              <a:t>Instant Deactivation</a:t>
-            </a:r>
-            <a:endParaRPr lang="en-US" sz="1300" dirty="0"/>
-          </a:p>
-        </p:txBody>
-      </p:sp>
-      <p:sp>
-        <p:nvSpPr>
-          <p:cNvPr id="23" name="Text 21"/>
-          <p:cNvSpPr/>
-          <p:nvPr/>
-        </p:nvSpPr>
-        <p:spPr>
-          <a:xfrm>
-            <a:off x="3017520" y="4187952"/>
-            <a:ext cx="5212080" cy="640080"/>
-          </a:xfrm>
-          <a:prstGeom prst="rect">
-            <a:avLst/>
-          </a:prstGeom>
-          <a:noFill/>
-          <a:ln/>
-        </p:spPr>
-        <p:txBody>
-          <a:bodyPr wrap="square" lIns="0" tIns="0" rIns="0" bIns="0" rtlCol="0" anchor="ctr"/>
-          <a:lstStyle/>
-          <a:p>
-            <a:pPr indent="0" marL="0">
-              <a:buNone/>
-            </a:pPr>
-            <a:r>
-              <a:rPr lang="en-US" sz="1100" dirty="0">
-                <a:solidFill>
-                  <a:srgbClr val="555555"/>
-                </a:solidFill>
-                <a:latin typeface="Arial" pitchFamily="34" charset="0"/>
-                <a:ea typeface="Arial" pitchFamily="34" charset="-122"/>
-                <a:cs typeface="Arial" pitchFamily="34" charset="-120"/>
-              </a:rPr>
-              <a:t>Admins can deactivate any card immediately from the dashboard. The card turns red at the next scan attempt.</a:t>
+              <a:rPr lang="en-US" sz="1100" i="1" dirty="0">
+                <a:solidFill>
+                  <a:srgbClr val="888888"/>
+                </a:solidFill>
+                <a:latin typeface="Arial" pitchFamily="34" charset="0"/>
+                <a:ea typeface="Arial" pitchFamily="34" charset="-122"/>
+                <a:cs typeface="Arial" pitchFamily="34" charset="-120"/>
+              </a:rPr>
+              <a:t>Screenshots don't work — cashiers verify the holder's name on screen and the card's scan history.</a:t>
             </a:r>
             <a:endParaRPr lang="en-US" sz="1100" dirty="0"/>
           </a:p>
@@ -4247,7 +3784,7 @@
         </p:nvSpPr>
         <p:spPr>
           <a:xfrm>
-            <a:off x="731520" y="320040"/>
+            <a:off x="731520" y="274320"/>
             <a:ext cx="8229600" cy="457200"/>
           </a:xfrm>
           <a:prstGeom prst="rect">
@@ -4264,7 +3801,7 @@
               <a:buNone/>
             </a:pPr>
             <a:r>
-              <a:rPr lang="en-US" sz="2200" b="1" dirty="0">
+              <a:rPr lang="en-US" sz="2000" b="1" dirty="0">
                 <a:solidFill>
                   <a:srgbClr val="C5A55A"/>
                 </a:solidFill>
@@ -4272,62 +3809,405 @@
                 <a:ea typeface="Arial Black" pitchFamily="34" charset="-122"/>
                 <a:cs typeface="Arial Black" pitchFamily="34" charset="-120"/>
               </a:rPr>
-              <a:t>SPONSOR DASHBOARDS AND PROMOTIONS</a:t>
-            </a:r>
-            <a:endParaRPr lang="en-US" sz="2200" dirty="0"/>
-          </a:p>
-        </p:txBody>
-      </p:sp>
-      <p:sp>
-        <p:nvSpPr>
-          <p:cNvPr id="4" name="Shape 2"/>
-          <p:cNvSpPr/>
-          <p:nvPr/>
-        </p:nvSpPr>
-        <p:spPr>
-          <a:xfrm>
-            <a:off x="548640" y="1005840"/>
-            <a:ext cx="3931920" cy="3200400"/>
-          </a:xfrm>
-          <a:prstGeom prst="rect">
-            <a:avLst/>
-          </a:prstGeom>
-          <a:solidFill>
-            <a:srgbClr val="0A1A35"/>
-          </a:solidFill>
-          <a:ln/>
-          <a:effectLst>
-            <a:outerShdw sx="100000" sy="100000" kx="0" ky="0" algn="bl" rotWithShape="0" blurRad="101600" dist="38100" dir="8100000">
-              <a:srgbClr val="000000">
-                <a:alpha val="20000"/>
-              </a:srgbClr>
-            </a:outerShdw>
-          </a:effectLst>
-        </p:spPr>
-      </p:sp>
-      <p:sp>
-        <p:nvSpPr>
-          <p:cNvPr id="5" name="Shape 3"/>
-          <p:cNvSpPr/>
-          <p:nvPr/>
-        </p:nvSpPr>
-        <p:spPr>
-          <a:xfrm>
-            <a:off x="548640" y="1005840"/>
-            <a:ext cx="3931920" cy="54864"/>
-          </a:xfrm>
-          <a:prstGeom prst="rect">
-            <a:avLst/>
-          </a:prstGeom>
-          <a:solidFill>
-            <a:srgbClr val="C5A55A"/>
-          </a:solidFill>
-          <a:ln/>
-        </p:spPr>
+              <a:t>SPONSOR DASHBOARDS &amp; PUSH PROMOTIONS</a:t>
+            </a:r>
+            <a:endParaRPr lang="en-US" sz="2000" dirty="0"/>
+          </a:p>
+        </p:txBody>
+      </p:sp>
+      <p:sp>
+        <p:nvSpPr>
+          <p:cNvPr id="4" name="Text 2"/>
+          <p:cNvSpPr/>
+          <p:nvPr/>
+        </p:nvSpPr>
+        <p:spPr>
+          <a:xfrm>
+            <a:off x="731520" y="914400"/>
+            <a:ext cx="3657600" cy="274320"/>
+          </a:xfrm>
+          <a:prstGeom prst="rect">
+            <a:avLst/>
+          </a:prstGeom>
+          <a:noFill/>
+          <a:ln/>
+        </p:spPr>
+        <p:txBody>
+          <a:bodyPr wrap="square" lIns="0" tIns="0" rIns="0" bIns="0" rtlCol="0" anchor="ctr"/>
+          <a:lstStyle/>
+          <a:p>
+            <a:pPr indent="0" marL="0">
+              <a:buNone/>
+            </a:pPr>
+            <a:r>
+              <a:rPr lang="en-US" sz="1200" dirty="0">
+                <a:solidFill>
+                  <a:srgbClr val="A0A0A0"/>
+                </a:solidFill>
+                <a:latin typeface="Arial" pitchFamily="34" charset="0"/>
+                <a:ea typeface="Arial" pitchFamily="34" charset="-122"/>
+                <a:cs typeface="Arial" pitchFamily="34" charset="-120"/>
+              </a:rPr>
+              <a:t>Each sponsor gets a private login showing:</a:t>
+            </a:r>
+            <a:endParaRPr lang="en-US" sz="1200" dirty="0"/>
+          </a:p>
+        </p:txBody>
+      </p:sp>
+      <p:sp>
+        <p:nvSpPr>
+          <p:cNvPr id="5" name="Text 3"/>
+          <p:cNvSpPr/>
+          <p:nvPr/>
+        </p:nvSpPr>
+        <p:spPr>
+          <a:xfrm>
+            <a:off x="731520" y="1234440"/>
+            <a:ext cx="3657600" cy="274320"/>
+          </a:xfrm>
+          <a:prstGeom prst="rect">
+            <a:avLst/>
+          </a:prstGeom>
+          <a:noFill/>
+          <a:ln/>
+        </p:spPr>
+        <p:txBody>
+          <a:bodyPr wrap="square" lIns="0" tIns="0" rIns="0" bIns="0" rtlCol="0" anchor="ctr"/>
+          <a:lstStyle/>
+          <a:p>
+            <a:pPr indent="0" marL="0">
+              <a:buNone/>
+            </a:pPr>
+            <a:r>
+              <a:rPr lang="en-US" sz="1200" dirty="0">
+                <a:solidFill>
+                  <a:srgbClr val="FFFFFF"/>
+                </a:solidFill>
+                <a:latin typeface="Arial" pitchFamily="34" charset="0"/>
+                <a:ea typeface="Arial" pitchFamily="34" charset="-122"/>
+                <a:cs typeface="Arial" pitchFamily="34" charset="-120"/>
+              </a:rPr>
+              <a:t>  Total visits from cardholders</a:t>
+            </a:r>
+            <a:endParaRPr lang="en-US" sz="1200" dirty="0"/>
+          </a:p>
+        </p:txBody>
+      </p:sp>
+      <p:sp>
+        <p:nvSpPr>
+          <p:cNvPr id="6" name="Text 4"/>
+          <p:cNvSpPr/>
+          <p:nvPr/>
+        </p:nvSpPr>
+        <p:spPr>
+          <a:xfrm>
+            <a:off x="731520" y="1554480"/>
+            <a:ext cx="3657600" cy="274320"/>
+          </a:xfrm>
+          <a:prstGeom prst="rect">
+            <a:avLst/>
+          </a:prstGeom>
+          <a:noFill/>
+          <a:ln/>
+        </p:spPr>
+        <p:txBody>
+          <a:bodyPr wrap="square" lIns="0" tIns="0" rIns="0" bIns="0" rtlCol="0" anchor="ctr"/>
+          <a:lstStyle/>
+          <a:p>
+            <a:pPr indent="0" marL="0">
+              <a:buNone/>
+            </a:pPr>
+            <a:r>
+              <a:rPr lang="en-US" sz="1200" dirty="0">
+                <a:solidFill>
+                  <a:srgbClr val="FFFFFF"/>
+                </a:solidFill>
+                <a:latin typeface="Arial" pitchFamily="34" charset="0"/>
+                <a:ea typeface="Arial" pitchFamily="34" charset="-122"/>
+                <a:cs typeface="Arial" pitchFamily="34" charset="-120"/>
+              </a:rPr>
+              <a:t>  Unique customer count</a:t>
+            </a:r>
+            <a:endParaRPr lang="en-US" sz="1200" dirty="0"/>
+          </a:p>
+        </p:txBody>
+      </p:sp>
+      <p:sp>
+        <p:nvSpPr>
+          <p:cNvPr id="7" name="Text 5"/>
+          <p:cNvSpPr/>
+          <p:nvPr/>
+        </p:nvSpPr>
+        <p:spPr>
+          <a:xfrm>
+            <a:off x="731520" y="1874520"/>
+            <a:ext cx="3657600" cy="274320"/>
+          </a:xfrm>
+          <a:prstGeom prst="rect">
+            <a:avLst/>
+          </a:prstGeom>
+          <a:noFill/>
+          <a:ln/>
+        </p:spPr>
+        <p:txBody>
+          <a:bodyPr wrap="square" lIns="0" tIns="0" rIns="0" bIns="0" rtlCol="0" anchor="ctr"/>
+          <a:lstStyle/>
+          <a:p>
+            <a:pPr indent="0" marL="0">
+              <a:buNone/>
+            </a:pPr>
+            <a:r>
+              <a:rPr lang="en-US" sz="1200" dirty="0">
+                <a:solidFill>
+                  <a:srgbClr val="FFFFFF"/>
+                </a:solidFill>
+                <a:latin typeface="Arial" pitchFamily="34" charset="0"/>
+                <a:ea typeface="Arial" pitchFamily="34" charset="-122"/>
+                <a:cs typeface="Arial" pitchFamily="34" charset="-120"/>
+              </a:rPr>
+              <a:t>  Visits by day</a:t>
+            </a:r>
+            <a:endParaRPr lang="en-US" sz="1200" dirty="0"/>
+          </a:p>
+        </p:txBody>
+      </p:sp>
+      <p:sp>
+        <p:nvSpPr>
+          <p:cNvPr id="8" name="Text 6"/>
+          <p:cNvSpPr/>
+          <p:nvPr/>
+        </p:nvSpPr>
+        <p:spPr>
+          <a:xfrm>
+            <a:off x="731520" y="2194560"/>
+            <a:ext cx="3657600" cy="274320"/>
+          </a:xfrm>
+          <a:prstGeom prst="rect">
+            <a:avLst/>
+          </a:prstGeom>
+          <a:noFill/>
+          <a:ln/>
+        </p:spPr>
+        <p:txBody>
+          <a:bodyPr wrap="square" lIns="0" tIns="0" rIns="0" bIns="0" rtlCol="0" anchor="ctr"/>
+          <a:lstStyle/>
+          <a:p>
+            <a:pPr indent="0" marL="0">
+              <a:buNone/>
+            </a:pPr>
+            <a:r>
+              <a:rPr lang="en-US" sz="1200" dirty="0">
+                <a:solidFill>
+                  <a:srgbClr val="FFFFFF"/>
+                </a:solidFill>
+                <a:latin typeface="Arial" pitchFamily="34" charset="0"/>
+                <a:ea typeface="Arial" pitchFamily="34" charset="-122"/>
+                <a:cs typeface="Arial" pitchFamily="34" charset="-120"/>
+              </a:rPr>
+              <a:t>  Recent scan history</a:t>
+            </a:r>
+            <a:endParaRPr lang="en-US" sz="1200" dirty="0"/>
+          </a:p>
+        </p:txBody>
+      </p:sp>
+      <p:sp>
+        <p:nvSpPr>
+          <p:cNvPr id="9" name="Text 7"/>
+          <p:cNvSpPr/>
+          <p:nvPr/>
+        </p:nvSpPr>
+        <p:spPr>
+          <a:xfrm>
+            <a:off x="731520" y="2697480"/>
+            <a:ext cx="3657600" cy="274320"/>
+          </a:xfrm>
+          <a:prstGeom prst="rect">
+            <a:avLst/>
+          </a:prstGeom>
+          <a:noFill/>
+          <a:ln/>
+        </p:spPr>
+        <p:txBody>
+          <a:bodyPr wrap="square" lIns="0" tIns="0" rIns="0" bIns="0" rtlCol="0" anchor="ctr"/>
+          <a:lstStyle/>
+          <a:p>
+            <a:pPr indent="0" marL="0">
+              <a:buNone/>
+            </a:pPr>
+            <a:r>
+              <a:rPr lang="en-US" sz="1200" dirty="0">
+                <a:solidFill>
+                  <a:srgbClr val="A0A0A0"/>
+                </a:solidFill>
+                <a:latin typeface="Arial" pitchFamily="34" charset="0"/>
+                <a:ea typeface="Arial" pitchFamily="34" charset="-122"/>
+                <a:cs typeface="Arial" pitchFamily="34" charset="-120"/>
+              </a:rPr>
+              <a:t>Push promotions let you:</a:t>
+            </a:r>
+            <a:endParaRPr lang="en-US" sz="1200" dirty="0"/>
+          </a:p>
+        </p:txBody>
+      </p:sp>
+      <p:sp>
+        <p:nvSpPr>
+          <p:cNvPr id="10" name="Text 8"/>
+          <p:cNvSpPr/>
+          <p:nvPr/>
+        </p:nvSpPr>
+        <p:spPr>
+          <a:xfrm>
+            <a:off x="731520" y="3017520"/>
+            <a:ext cx="3657600" cy="274320"/>
+          </a:xfrm>
+          <a:prstGeom prst="rect">
+            <a:avLst/>
+          </a:prstGeom>
+          <a:noFill/>
+          <a:ln/>
+        </p:spPr>
+        <p:txBody>
+          <a:bodyPr wrap="square" lIns="0" tIns="0" rIns="0" bIns="0" rtlCol="0" anchor="ctr"/>
+          <a:lstStyle/>
+          <a:p>
+            <a:pPr indent="0" marL="0">
+              <a:buNone/>
+            </a:pPr>
+            <a:r>
+              <a:rPr lang="en-US" sz="1200" dirty="0">
+                <a:solidFill>
+                  <a:srgbClr val="FFFFFF"/>
+                </a:solidFill>
+                <a:latin typeface="Arial" pitchFamily="34" charset="0"/>
+                <a:ea typeface="Arial" pitchFamily="34" charset="-122"/>
+                <a:cs typeface="Arial" pitchFamily="34" charset="-120"/>
+              </a:rPr>
+              <a:t>  Send deals to every cardholder's phone</a:t>
+            </a:r>
+            <a:endParaRPr lang="en-US" sz="1200" dirty="0"/>
+          </a:p>
+        </p:txBody>
+      </p:sp>
+      <p:sp>
+        <p:nvSpPr>
+          <p:cNvPr id="11" name="Text 9"/>
+          <p:cNvSpPr/>
+          <p:nvPr/>
+        </p:nvSpPr>
+        <p:spPr>
+          <a:xfrm>
+            <a:off x="731520" y="3337560"/>
+            <a:ext cx="3657600" cy="274320"/>
+          </a:xfrm>
+          <a:prstGeom prst="rect">
+            <a:avLst/>
+          </a:prstGeom>
+          <a:noFill/>
+          <a:ln/>
+        </p:spPr>
+        <p:txBody>
+          <a:bodyPr wrap="square" lIns="0" tIns="0" rIns="0" bIns="0" rtlCol="0" anchor="ctr"/>
+          <a:lstStyle/>
+          <a:p>
+            <a:pPr indent="0" marL="0">
+              <a:buNone/>
+            </a:pPr>
+            <a:r>
+              <a:rPr lang="en-US" sz="1200" dirty="0">
+                <a:solidFill>
+                  <a:srgbClr val="FFFFFF"/>
+                </a:solidFill>
+                <a:latin typeface="Arial" pitchFamily="34" charset="0"/>
+                <a:ea typeface="Arial" pitchFamily="34" charset="-122"/>
+                <a:cs typeface="Arial" pitchFamily="34" charset="-120"/>
+              </a:rPr>
+              <a:t>  Lock-screen notification on every iPhone</a:t>
+            </a:r>
+            <a:endParaRPr lang="en-US" sz="1200" dirty="0"/>
+          </a:p>
+        </p:txBody>
+      </p:sp>
+      <p:sp>
+        <p:nvSpPr>
+          <p:cNvPr id="12" name="Text 10"/>
+          <p:cNvSpPr/>
+          <p:nvPr/>
+        </p:nvSpPr>
+        <p:spPr>
+          <a:xfrm>
+            <a:off x="731520" y="3657600"/>
+            <a:ext cx="3657600" cy="274320"/>
+          </a:xfrm>
+          <a:prstGeom prst="rect">
+            <a:avLst/>
+          </a:prstGeom>
+          <a:noFill/>
+          <a:ln/>
+        </p:spPr>
+        <p:txBody>
+          <a:bodyPr wrap="square" lIns="0" tIns="0" rIns="0" bIns="0" rtlCol="0" anchor="ctr"/>
+          <a:lstStyle/>
+          <a:p>
+            <a:pPr indent="0" marL="0">
+              <a:buNone/>
+            </a:pPr>
+            <a:r>
+              <a:rPr lang="en-US" sz="1200" dirty="0">
+                <a:solidFill>
+                  <a:srgbClr val="FFFFFF"/>
+                </a:solidFill>
+                <a:latin typeface="Arial" pitchFamily="34" charset="0"/>
+                <a:ea typeface="Arial" pitchFamily="34" charset="-122"/>
+                <a:cs typeface="Arial" pitchFamily="34" charset="-120"/>
+              </a:rPr>
+              <a:t>  Card updates automatically in Wallet</a:t>
+            </a:r>
+            <a:endParaRPr lang="en-US" sz="1200" dirty="0"/>
+          </a:p>
+        </p:txBody>
+      </p:sp>
+      <p:sp>
+        <p:nvSpPr>
+          <p:cNvPr id="13" name="Text 11"/>
+          <p:cNvSpPr/>
+          <p:nvPr/>
+        </p:nvSpPr>
+        <p:spPr>
+          <a:xfrm>
+            <a:off x="731520" y="3977640"/>
+            <a:ext cx="3657600" cy="274320"/>
+          </a:xfrm>
+          <a:prstGeom prst="rect">
+            <a:avLst/>
+          </a:prstGeom>
+          <a:noFill/>
+          <a:ln/>
+        </p:spPr>
+        <p:txBody>
+          <a:bodyPr wrap="square" lIns="0" tIns="0" rIns="0" bIns="0" rtlCol="0" anchor="ctr"/>
+          <a:lstStyle/>
+          <a:p>
+            <a:pPr indent="0" marL="0">
+              <a:buNone/>
+            </a:pPr>
+            <a:r>
+              <a:rPr lang="en-US" sz="1200" dirty="0">
+                <a:solidFill>
+                  <a:srgbClr val="FFFFFF"/>
+                </a:solidFill>
+                <a:latin typeface="Arial" pitchFamily="34" charset="0"/>
+                <a:ea typeface="Arial" pitchFamily="34" charset="-122"/>
+                <a:cs typeface="Arial" pitchFamily="34" charset="-120"/>
+              </a:rPr>
+              <a:t>  Promotions can have expiration dates</a:t>
+            </a:r>
+            <a:endParaRPr lang="en-US" sz="1200" dirty="0"/>
+          </a:p>
+        </p:txBody>
       </p:sp>
       <p:pic>
         <p:nvPicPr>
-          <p:cNvPr id="6" name="Image 0" descr="preencoded.png">    </p:cNvPr>
+          <p:cNvPr id="14" name="Image 0" descr="preencoded.png">    </p:cNvPr>
           <p:cNvPicPr>
             <a:picLocks noChangeAspect="1"/>
           </p:cNvPicPr>
@@ -4335,14 +4215,13 @@
         </p:nvPicPr>
         <p:blipFill>
           <a:blip r:embed="rId1"/>
-          <a:stretch>
-            <a:fillRect/>
-          </a:stretch>
+          <a:srcRect l="0" r="0" t="0" b="0"/>
+          <a:stretch/>
         </p:blipFill>
         <p:spPr>
           <a:xfrm>
-            <a:off x="822960" y="1143000"/>
-            <a:ext cx="365760" cy="365760"/>
+            <a:off x="4572000" y="822960"/>
+            <a:ext cx="4389120" cy="2505456"/>
           </a:xfrm>
           <a:prstGeom prst="rect">
             <a:avLst/>
@@ -4351,14 +4230,14 @@
       </p:pic>
       <p:sp>
         <p:nvSpPr>
-          <p:cNvPr id="7" name="Text 4"/>
-          <p:cNvSpPr/>
-          <p:nvPr/>
-        </p:nvSpPr>
-        <p:spPr>
-          <a:xfrm>
-            <a:off x="1280160" y="1143000"/>
-            <a:ext cx="2926080" cy="365760"/>
+          <p:cNvPr id="15" name="Text 12"/>
+          <p:cNvSpPr/>
+          <p:nvPr/>
+        </p:nvSpPr>
+        <p:spPr>
+          <a:xfrm>
+            <a:off x="731520" y="4480560"/>
+            <a:ext cx="7680960" cy="274320"/>
           </a:xfrm>
           <a:prstGeom prst="rect">
             <a:avLst/>
@@ -4374,46 +4253,7 @@
               <a:buNone/>
             </a:pPr>
             <a:r>
-              <a:rPr lang="en-US" sz="1400" b="1" dirty="0">
-                <a:solidFill>
-                  <a:srgbClr val="C5A55A"/>
-                </a:solidFill>
-                <a:latin typeface="Arial" pitchFamily="34" charset="0"/>
-                <a:ea typeface="Arial" pitchFamily="34" charset="-122"/>
-                <a:cs typeface="Arial" pitchFamily="34" charset="-120"/>
-              </a:rPr>
-              <a:t>SPONSOR DASHBOARDS</a:t>
-            </a:r>
-            <a:endParaRPr lang="en-US" sz="1400" dirty="0"/>
-          </a:p>
-        </p:txBody>
-      </p:sp>
-      <p:sp>
-        <p:nvSpPr>
-          <p:cNvPr id="8" name="Text 5"/>
-          <p:cNvSpPr/>
-          <p:nvPr/>
-        </p:nvSpPr>
-        <p:spPr>
-          <a:xfrm>
-            <a:off x="822960" y="1600200"/>
-            <a:ext cx="3474720" cy="320040"/>
-          </a:xfrm>
-          <a:prstGeom prst="rect">
-            <a:avLst/>
-          </a:prstGeom>
-          <a:noFill/>
-          <a:ln/>
-        </p:spPr>
-        <p:txBody>
-          <a:bodyPr wrap="square" lIns="0" tIns="0" rIns="0" bIns="0" rtlCol="0" anchor="ctr"/>
-          <a:lstStyle/>
-          <a:p>
-            <a:pPr indent="0" marL="0">
-              <a:buNone/>
-            </a:pPr>
-            <a:r>
-              <a:rPr lang="en-US" sz="1200" dirty="0">
+              <a:rPr lang="en-US" sz="1000" i="1" dirty="0">
                 <a:solidFill>
                   <a:srgbClr val="A0A0A0"/>
                 </a:solidFill>
@@ -4421,636 +4261,7 @@
                 <a:ea typeface="Arial" pitchFamily="34" charset="-122"/>
                 <a:cs typeface="Arial" pitchFamily="34" charset="-120"/>
               </a:rPr>
-              <a:t>Each business gets a private login to see:</a:t>
-            </a:r>
-            <a:endParaRPr lang="en-US" sz="1200" dirty="0"/>
-          </a:p>
-        </p:txBody>
-      </p:sp>
-      <p:sp>
-        <p:nvSpPr>
-          <p:cNvPr id="9" name="Text 6"/>
-          <p:cNvSpPr/>
-          <p:nvPr/>
-        </p:nvSpPr>
-        <p:spPr>
-          <a:xfrm>
-            <a:off x="822960" y="2011680"/>
-            <a:ext cx="3474720" cy="320040"/>
-          </a:xfrm>
-          <a:prstGeom prst="rect">
-            <a:avLst/>
-          </a:prstGeom>
-          <a:noFill/>
-          <a:ln/>
-        </p:spPr>
-        <p:txBody>
-          <a:bodyPr wrap="square" lIns="0" tIns="0" rIns="0" bIns="0" rtlCol="0" anchor="ctr"/>
-          <a:lstStyle/>
-          <a:p>
-            <a:pPr indent="0" marL="0">
-              <a:buNone/>
-            </a:pPr>
-            <a:r>
-              <a:rPr lang="en-US" sz="1200" dirty="0">
-                <a:solidFill>
-                  <a:srgbClr val="FFFFFF"/>
-                </a:solidFill>
-                <a:latin typeface="Arial" pitchFamily="34" charset="0"/>
-                <a:ea typeface="Arial" pitchFamily="34" charset="-122"/>
-                <a:cs typeface="Arial" pitchFamily="34" charset="-120"/>
-              </a:rPr>
-              <a:t>  Total visits from cardholders</a:t>
-            </a:r>
-            <a:endParaRPr lang="en-US" sz="1200" dirty="0"/>
-          </a:p>
-        </p:txBody>
-      </p:sp>
-      <p:sp>
-        <p:nvSpPr>
-          <p:cNvPr id="10" name="Text 7"/>
-          <p:cNvSpPr/>
-          <p:nvPr/>
-        </p:nvSpPr>
-        <p:spPr>
-          <a:xfrm>
-            <a:off x="822960" y="2377440"/>
-            <a:ext cx="3474720" cy="320040"/>
-          </a:xfrm>
-          <a:prstGeom prst="rect">
-            <a:avLst/>
-          </a:prstGeom>
-          <a:noFill/>
-          <a:ln/>
-        </p:spPr>
-        <p:txBody>
-          <a:bodyPr wrap="square" lIns="0" tIns="0" rIns="0" bIns="0" rtlCol="0" anchor="ctr"/>
-          <a:lstStyle/>
-          <a:p>
-            <a:pPr indent="0" marL="0">
-              <a:buNone/>
-            </a:pPr>
-            <a:r>
-              <a:rPr lang="en-US" sz="1200" dirty="0">
-                <a:solidFill>
-                  <a:srgbClr val="FFFFFF"/>
-                </a:solidFill>
-                <a:latin typeface="Arial" pitchFamily="34" charset="0"/>
-                <a:ea typeface="Arial" pitchFamily="34" charset="-122"/>
-                <a:cs typeface="Arial" pitchFamily="34" charset="-120"/>
-              </a:rPr>
-              <a:t>  Unique customer count</a:t>
-            </a:r>
-            <a:endParaRPr lang="en-US" sz="1200" dirty="0"/>
-          </a:p>
-        </p:txBody>
-      </p:sp>
-      <p:sp>
-        <p:nvSpPr>
-          <p:cNvPr id="11" name="Text 8"/>
-          <p:cNvSpPr/>
-          <p:nvPr/>
-        </p:nvSpPr>
-        <p:spPr>
-          <a:xfrm>
-            <a:off x="822960" y="2743200"/>
-            <a:ext cx="3474720" cy="320040"/>
-          </a:xfrm>
-          <a:prstGeom prst="rect">
-            <a:avLst/>
-          </a:prstGeom>
-          <a:noFill/>
-          <a:ln/>
-        </p:spPr>
-        <p:txBody>
-          <a:bodyPr wrap="square" lIns="0" tIns="0" rIns="0" bIns="0" rtlCol="0" anchor="ctr"/>
-          <a:lstStyle/>
-          <a:p>
-            <a:pPr indent="0" marL="0">
-              <a:buNone/>
-            </a:pPr>
-            <a:r>
-              <a:rPr lang="en-US" sz="1200" dirty="0">
-                <a:solidFill>
-                  <a:srgbClr val="FFFFFF"/>
-                </a:solidFill>
-                <a:latin typeface="Arial" pitchFamily="34" charset="0"/>
-                <a:ea typeface="Arial" pitchFamily="34" charset="-122"/>
-                <a:cs typeface="Arial" pitchFamily="34" charset="-120"/>
-              </a:rPr>
-              <a:t>  Visits broken down by day</a:t>
-            </a:r>
-            <a:endParaRPr lang="en-US" sz="1200" dirty="0"/>
-          </a:p>
-        </p:txBody>
-      </p:sp>
-      <p:sp>
-        <p:nvSpPr>
-          <p:cNvPr id="12" name="Text 9"/>
-          <p:cNvSpPr/>
-          <p:nvPr/>
-        </p:nvSpPr>
-        <p:spPr>
-          <a:xfrm>
-            <a:off x="822960" y="3108960"/>
-            <a:ext cx="3474720" cy="320040"/>
-          </a:xfrm>
-          <a:prstGeom prst="rect">
-            <a:avLst/>
-          </a:prstGeom>
-          <a:noFill/>
-          <a:ln/>
-        </p:spPr>
-        <p:txBody>
-          <a:bodyPr wrap="square" lIns="0" tIns="0" rIns="0" bIns="0" rtlCol="0" anchor="ctr"/>
-          <a:lstStyle/>
-          <a:p>
-            <a:pPr indent="0" marL="0">
-              <a:buNone/>
-            </a:pPr>
-            <a:r>
-              <a:rPr lang="en-US" sz="1200" dirty="0">
-                <a:solidFill>
-                  <a:srgbClr val="FFFFFF"/>
-                </a:solidFill>
-                <a:latin typeface="Arial" pitchFamily="34" charset="0"/>
-                <a:ea typeface="Arial" pitchFamily="34" charset="-122"/>
-                <a:cs typeface="Arial" pitchFamily="34" charset="-120"/>
-              </a:rPr>
-              <a:t>  Recent scan history with dates</a:t>
-            </a:r>
-            <a:endParaRPr lang="en-US" sz="1200" dirty="0"/>
-          </a:p>
-        </p:txBody>
-      </p:sp>
-      <p:sp>
-        <p:nvSpPr>
-          <p:cNvPr id="13" name="Text 10"/>
-          <p:cNvSpPr/>
-          <p:nvPr/>
-        </p:nvSpPr>
-        <p:spPr>
-          <a:xfrm>
-            <a:off x="822960" y="3566160"/>
-            <a:ext cx="3474720" cy="548640"/>
-          </a:xfrm>
-          <a:prstGeom prst="rect">
-            <a:avLst/>
-          </a:prstGeom>
-          <a:noFill/>
-          <a:ln/>
-        </p:spPr>
-        <p:txBody>
-          <a:bodyPr wrap="square" lIns="0" tIns="0" rIns="0" bIns="0" rtlCol="0" anchor="ctr"/>
-          <a:lstStyle/>
-          <a:p>
-            <a:pPr indent="0" marL="0">
-              <a:buNone/>
-            </a:pPr>
-            <a:r>
-              <a:rPr lang="en-US" sz="1100" i="1" dirty="0">
-                <a:solidFill>
-                  <a:srgbClr val="D4B96A"/>
-                </a:solidFill>
-                <a:latin typeface="Arial" pitchFamily="34" charset="0"/>
-                <a:ea typeface="Arial" pitchFamily="34" charset="-122"/>
-                <a:cs typeface="Arial" pitchFamily="34" charset="-120"/>
-              </a:rPr>
-              <a:t>No app needed. Works on any phone or computer.</a:t>
-            </a:r>
-            <a:endParaRPr lang="en-US" sz="1100" dirty="0"/>
-          </a:p>
-          <a:p>
-            <a:pPr indent="0" marL="0">
-              <a:buNone/>
-            </a:pPr>
-            <a:r>
-              <a:rPr lang="en-US" sz="1100" i="1" dirty="0">
-                <a:solidFill>
-                  <a:srgbClr val="D4B96A"/>
-                </a:solidFill>
-                <a:latin typeface="Arial" pitchFamily="34" charset="0"/>
-                <a:ea typeface="Arial" pitchFamily="34" charset="-122"/>
-                <a:cs typeface="Arial" pitchFamily="34" charset="-120"/>
-              </a:rPr>
-              <a:t>Access via a simple code — no passwords.</a:t>
-            </a:r>
-            <a:endParaRPr lang="en-US" sz="1100" dirty="0"/>
-          </a:p>
-        </p:txBody>
-      </p:sp>
-      <p:sp>
-        <p:nvSpPr>
-          <p:cNvPr id="14" name="Shape 11"/>
-          <p:cNvSpPr/>
-          <p:nvPr/>
-        </p:nvSpPr>
-        <p:spPr>
-          <a:xfrm>
-            <a:off x="4663440" y="1005840"/>
-            <a:ext cx="3931920" cy="3200400"/>
-          </a:xfrm>
-          <a:prstGeom prst="rect">
-            <a:avLst/>
-          </a:prstGeom>
-          <a:solidFill>
-            <a:srgbClr val="0A1A35"/>
-          </a:solidFill>
-          <a:ln/>
-          <a:effectLst>
-            <a:outerShdw sx="100000" sy="100000" kx="0" ky="0" algn="bl" rotWithShape="0" blurRad="101600" dist="38100" dir="8100000">
-              <a:srgbClr val="000000">
-                <a:alpha val="20000"/>
-              </a:srgbClr>
-            </a:outerShdw>
-          </a:effectLst>
-        </p:spPr>
-      </p:sp>
-      <p:sp>
-        <p:nvSpPr>
-          <p:cNvPr id="15" name="Shape 12"/>
-          <p:cNvSpPr/>
-          <p:nvPr/>
-        </p:nvSpPr>
-        <p:spPr>
-          <a:xfrm>
-            <a:off x="4663440" y="1005840"/>
-            <a:ext cx="3931920" cy="54864"/>
-          </a:xfrm>
-          <a:prstGeom prst="rect">
-            <a:avLst/>
-          </a:prstGeom>
-          <a:solidFill>
-            <a:srgbClr val="C5A55A"/>
-          </a:solidFill>
-          <a:ln/>
-        </p:spPr>
-      </p:sp>
-      <p:pic>
-        <p:nvPicPr>
-          <p:cNvPr id="16" name="Image 1" descr="preencoded.png">    </p:cNvPr>
-          <p:cNvPicPr>
-            <a:picLocks noChangeAspect="1"/>
-          </p:cNvPicPr>
-          <p:nvPr/>
-        </p:nvPicPr>
-        <p:blipFill>
-          <a:blip r:embed="rId2"/>
-          <a:stretch>
-            <a:fillRect/>
-          </a:stretch>
-        </p:blipFill>
-        <p:spPr>
-          <a:xfrm>
-            <a:off x="4937760" y="1143000"/>
-            <a:ext cx="365760" cy="365760"/>
-          </a:xfrm>
-          <a:prstGeom prst="rect">
-            <a:avLst/>
-          </a:prstGeom>
-        </p:spPr>
-      </p:pic>
-      <p:sp>
-        <p:nvSpPr>
-          <p:cNvPr id="17" name="Text 13"/>
-          <p:cNvSpPr/>
-          <p:nvPr/>
-        </p:nvSpPr>
-        <p:spPr>
-          <a:xfrm>
-            <a:off x="5394960" y="1143000"/>
-            <a:ext cx="2926080" cy="365760"/>
-          </a:xfrm>
-          <a:prstGeom prst="rect">
-            <a:avLst/>
-          </a:prstGeom>
-          <a:noFill/>
-          <a:ln/>
-        </p:spPr>
-        <p:txBody>
-          <a:bodyPr wrap="square" lIns="0" tIns="0" rIns="0" bIns="0" rtlCol="0" anchor="ctr"/>
-          <a:lstStyle/>
-          <a:p>
-            <a:pPr indent="0" marL="0">
-              <a:buNone/>
-            </a:pPr>
-            <a:r>
-              <a:rPr lang="en-US" sz="1400" b="1" dirty="0">
-                <a:solidFill>
-                  <a:srgbClr val="C5A55A"/>
-                </a:solidFill>
-                <a:latin typeface="Arial" pitchFamily="34" charset="0"/>
-                <a:ea typeface="Arial" pitchFamily="34" charset="-122"/>
-                <a:cs typeface="Arial" pitchFamily="34" charset="-120"/>
-              </a:rPr>
-              <a:t>PUSH PROMOTIONS</a:t>
-            </a:r>
-            <a:endParaRPr lang="en-US" sz="1400" dirty="0"/>
-          </a:p>
-        </p:txBody>
-      </p:sp>
-      <p:sp>
-        <p:nvSpPr>
-          <p:cNvPr id="18" name="Text 14"/>
-          <p:cNvSpPr/>
-          <p:nvPr/>
-        </p:nvSpPr>
-        <p:spPr>
-          <a:xfrm>
-            <a:off x="4937760" y="1600200"/>
-            <a:ext cx="3474720" cy="457200"/>
-          </a:xfrm>
-          <a:prstGeom prst="rect">
-            <a:avLst/>
-          </a:prstGeom>
-          <a:noFill/>
-          <a:ln/>
-        </p:spPr>
-        <p:txBody>
-          <a:bodyPr wrap="square" lIns="0" tIns="0" rIns="0" bIns="0" rtlCol="0" anchor="ctr"/>
-          <a:lstStyle/>
-          <a:p>
-            <a:pPr indent="0" marL="0">
-              <a:buNone/>
-            </a:pPr>
-            <a:r>
-              <a:rPr lang="en-US" sz="1200" dirty="0">
-                <a:solidFill>
-                  <a:srgbClr val="A0A0A0"/>
-                </a:solidFill>
-                <a:latin typeface="Arial" pitchFamily="34" charset="0"/>
-                <a:ea typeface="Arial" pitchFamily="34" charset="-122"/>
-                <a:cs typeface="Arial" pitchFamily="34" charset="-120"/>
-              </a:rPr>
-              <a:t>Admin creates a promotion and pushes</a:t>
-            </a:r>
-            <a:endParaRPr lang="en-US" sz="1200" dirty="0"/>
-          </a:p>
-          <a:p>
-            <a:pPr indent="0" marL="0">
-              <a:buNone/>
-            </a:pPr>
-            <a:r>
-              <a:rPr lang="en-US" sz="1200" dirty="0">
-                <a:solidFill>
-                  <a:srgbClr val="A0A0A0"/>
-                </a:solidFill>
-                <a:latin typeface="Arial" pitchFamily="34" charset="0"/>
-                <a:ea typeface="Arial" pitchFamily="34" charset="-122"/>
-                <a:cs typeface="Arial" pitchFamily="34" charset="-120"/>
-              </a:rPr>
-              <a:t>to every cardholder's phone:</a:t>
-            </a:r>
-            <a:endParaRPr lang="en-US" sz="1200" dirty="0"/>
-          </a:p>
-        </p:txBody>
-      </p:sp>
-      <p:sp>
-        <p:nvSpPr>
-          <p:cNvPr id="19" name="Text 15"/>
-          <p:cNvSpPr/>
-          <p:nvPr/>
-        </p:nvSpPr>
-        <p:spPr>
-          <a:xfrm>
-            <a:off x="4937760" y="2148840"/>
-            <a:ext cx="3474720" cy="320040"/>
-          </a:xfrm>
-          <a:prstGeom prst="rect">
-            <a:avLst/>
-          </a:prstGeom>
-          <a:noFill/>
-          <a:ln/>
-        </p:spPr>
-        <p:txBody>
-          <a:bodyPr wrap="square" lIns="0" tIns="0" rIns="0" bIns="0" rtlCol="0" anchor="ctr"/>
-          <a:lstStyle/>
-          <a:p>
-            <a:pPr indent="0" marL="0">
-              <a:buNone/>
-            </a:pPr>
-            <a:r>
-              <a:rPr lang="en-US" sz="1200" dirty="0">
-                <a:solidFill>
-                  <a:srgbClr val="FFFFFF"/>
-                </a:solidFill>
-                <a:latin typeface="Arial" pitchFamily="34" charset="0"/>
-                <a:ea typeface="Arial" pitchFamily="34" charset="-122"/>
-                <a:cs typeface="Arial" pitchFamily="34" charset="-120"/>
-              </a:rPr>
-              <a:t>1. Admin types the deal in the dashboard</a:t>
-            </a:r>
-            <a:endParaRPr lang="en-US" sz="1200" dirty="0"/>
-          </a:p>
-        </p:txBody>
-      </p:sp>
-      <p:sp>
-        <p:nvSpPr>
-          <p:cNvPr id="20" name="Text 16"/>
-          <p:cNvSpPr/>
-          <p:nvPr/>
-        </p:nvSpPr>
-        <p:spPr>
-          <a:xfrm>
-            <a:off x="4937760" y="2514600"/>
-            <a:ext cx="3474720" cy="320040"/>
-          </a:xfrm>
-          <a:prstGeom prst="rect">
-            <a:avLst/>
-          </a:prstGeom>
-          <a:noFill/>
-          <a:ln/>
-        </p:spPr>
-        <p:txBody>
-          <a:bodyPr wrap="square" lIns="0" tIns="0" rIns="0" bIns="0" rtlCol="0" anchor="ctr"/>
-          <a:lstStyle/>
-          <a:p>
-            <a:pPr indent="0" marL="0">
-              <a:buNone/>
-            </a:pPr>
-            <a:r>
-              <a:rPr lang="en-US" sz="1200" dirty="0">
-                <a:solidFill>
-                  <a:srgbClr val="FFFFFF"/>
-                </a:solidFill>
-                <a:latin typeface="Arial" pitchFamily="34" charset="0"/>
-                <a:ea typeface="Arial" pitchFamily="34" charset="-122"/>
-                <a:cs typeface="Arial" pitchFamily="34" charset="-120"/>
-              </a:rPr>
-              <a:t>2. Clicks "Push to All Devices"</a:t>
-            </a:r>
-            <a:endParaRPr lang="en-US" sz="1200" dirty="0"/>
-          </a:p>
-        </p:txBody>
-      </p:sp>
-      <p:sp>
-        <p:nvSpPr>
-          <p:cNvPr id="21" name="Text 17"/>
-          <p:cNvSpPr/>
-          <p:nvPr/>
-        </p:nvSpPr>
-        <p:spPr>
-          <a:xfrm>
-            <a:off x="4937760" y="2880360"/>
-            <a:ext cx="3474720" cy="320040"/>
-          </a:xfrm>
-          <a:prstGeom prst="rect">
-            <a:avLst/>
-          </a:prstGeom>
-          <a:noFill/>
-          <a:ln/>
-        </p:spPr>
-        <p:txBody>
-          <a:bodyPr wrap="square" lIns="0" tIns="0" rIns="0" bIns="0" rtlCol="0" anchor="ctr"/>
-          <a:lstStyle/>
-          <a:p>
-            <a:pPr indent="0" marL="0">
-              <a:buNone/>
-            </a:pPr>
-            <a:r>
-              <a:rPr lang="en-US" sz="1200" dirty="0">
-                <a:solidFill>
-                  <a:srgbClr val="FFFFFF"/>
-                </a:solidFill>
-                <a:latin typeface="Arial" pitchFamily="34" charset="0"/>
-                <a:ea typeface="Arial" pitchFamily="34" charset="-122"/>
-                <a:cs typeface="Arial" pitchFamily="34" charset="-120"/>
-              </a:rPr>
-              <a:t>3. Every iPhone gets a lock-screen notification</a:t>
-            </a:r>
-            <a:endParaRPr lang="en-US" sz="1200" dirty="0"/>
-          </a:p>
-        </p:txBody>
-      </p:sp>
-      <p:sp>
-        <p:nvSpPr>
-          <p:cNvPr id="22" name="Text 18"/>
-          <p:cNvSpPr/>
-          <p:nvPr/>
-        </p:nvSpPr>
-        <p:spPr>
-          <a:xfrm>
-            <a:off x="4937760" y="3246120"/>
-            <a:ext cx="3474720" cy="320040"/>
-          </a:xfrm>
-          <a:prstGeom prst="rect">
-            <a:avLst/>
-          </a:prstGeom>
-          <a:noFill/>
-          <a:ln/>
-        </p:spPr>
-        <p:txBody>
-          <a:bodyPr wrap="square" lIns="0" tIns="0" rIns="0" bIns="0" rtlCol="0" anchor="ctr"/>
-          <a:lstStyle/>
-          <a:p>
-            <a:pPr indent="0" marL="0">
-              <a:buNone/>
-            </a:pPr>
-            <a:r>
-              <a:rPr lang="en-US" sz="1200" dirty="0">
-                <a:solidFill>
-                  <a:srgbClr val="FFFFFF"/>
-                </a:solidFill>
-                <a:latin typeface="Arial" pitchFamily="34" charset="0"/>
-                <a:ea typeface="Arial" pitchFamily="34" charset="-122"/>
-                <a:cs typeface="Arial" pitchFamily="34" charset="-120"/>
-              </a:rPr>
-              <a:t>4. Card in Wallet updates automatically</a:t>
-            </a:r>
-            <a:endParaRPr lang="en-US" sz="1200" dirty="0"/>
-          </a:p>
-        </p:txBody>
-      </p:sp>
-      <p:sp>
-        <p:nvSpPr>
-          <p:cNvPr id="23" name="Text 19"/>
-          <p:cNvSpPr/>
-          <p:nvPr/>
-        </p:nvSpPr>
-        <p:spPr>
-          <a:xfrm>
-            <a:off x="4937760" y="3566160"/>
-            <a:ext cx="3474720" cy="548640"/>
-          </a:xfrm>
-          <a:prstGeom prst="rect">
-            <a:avLst/>
-          </a:prstGeom>
-          <a:noFill/>
-          <a:ln/>
-        </p:spPr>
-        <p:txBody>
-          <a:bodyPr wrap="square" lIns="0" tIns="0" rIns="0" bIns="0" rtlCol="0" anchor="ctr"/>
-          <a:lstStyle/>
-          <a:p>
-            <a:pPr indent="0" marL="0">
-              <a:buNone/>
-            </a:pPr>
-            <a:r>
-              <a:rPr lang="en-US" sz="1100" i="1" dirty="0">
-                <a:solidFill>
-                  <a:srgbClr val="D4B96A"/>
-                </a:solidFill>
-                <a:latin typeface="Arial" pitchFamily="34" charset="0"/>
-                <a:ea typeface="Arial" pitchFamily="34" charset="-122"/>
-                <a:cs typeface="Arial" pitchFamily="34" charset="-120"/>
-              </a:rPr>
-              <a:t>Sponsors request promos before game days.</a:t>
-            </a:r>
-            <a:endParaRPr lang="en-US" sz="1100" dirty="0"/>
-          </a:p>
-          <a:p>
-            <a:pPr indent="0" marL="0">
-              <a:buNone/>
-            </a:pPr>
-            <a:r>
-              <a:rPr lang="en-US" sz="1100" i="1" dirty="0">
-                <a:solidFill>
-                  <a:srgbClr val="D4B96A"/>
-                </a:solidFill>
-                <a:latin typeface="Arial" pitchFamily="34" charset="0"/>
-                <a:ea typeface="Arial" pitchFamily="34" charset="-122"/>
-                <a:cs typeface="Arial" pitchFamily="34" charset="-120"/>
-              </a:rPr>
-              <a:t>Gold tier: 2/month. Silver: 1/month.</a:t>
-            </a:r>
-            <a:endParaRPr lang="en-US" sz="1100" dirty="0"/>
-          </a:p>
-        </p:txBody>
-      </p:sp>
-      <p:sp>
-        <p:nvSpPr>
-          <p:cNvPr id="24" name="Text 20"/>
-          <p:cNvSpPr/>
-          <p:nvPr/>
-        </p:nvSpPr>
-        <p:spPr>
-          <a:xfrm>
-            <a:off x="731520" y="4480560"/>
-            <a:ext cx="7680960" cy="365760"/>
-          </a:xfrm>
-          <a:prstGeom prst="rect">
-            <a:avLst/>
-          </a:prstGeom>
-          <a:noFill/>
-          <a:ln/>
-        </p:spPr>
-        <p:txBody>
-          <a:bodyPr wrap="square" lIns="0" tIns="0" rIns="0" bIns="0" rtlCol="0" anchor="ctr"/>
-          <a:lstStyle/>
-          <a:p>
-            <a:pPr indent="0" marL="0">
-              <a:buNone/>
-            </a:pPr>
-            <a:r>
-              <a:rPr lang="en-US" sz="1000" i="1" dirty="0">
-                <a:solidFill>
-                  <a:srgbClr val="A0A0A0"/>
-                </a:solidFill>
-                <a:latin typeface="Arial" pitchFamily="34" charset="0"/>
-                <a:ea typeface="Arial" pitchFamily="34" charset="-122"/>
-                <a:cs typeface="Arial" pitchFamily="34" charset="-120"/>
-              </a:rPr>
-              <a:t>Terms &amp; Conditions, Privacy Policy, and Sponsor Agreement govern all data usage and program participation.</a:t>
+              <a:t>Terms &amp; Conditions, Privacy Policy, and Sponsor Agreement govern all data usage.</a:t>
             </a:r>
             <a:endParaRPr lang="en-US" sz="1000" dirty="0"/>
           </a:p>

</xml_diff>

<commit_message>
Add real DN Nighthawk logo from dnfootball.com to decks and pass model
- Downloaded official Nighthawk head logo and text logo from dnfootball.com
- Replaced placeholder football icons with real Nighthawk logo on title and
  closing slides of both decks
- Updated Apple Wallet pass model with real logo images (icon, logo)
- Both decks rebuilt with Nighthawk branding

Co-Authored-By: Claude Opus 4.6 (1M context) <noreply@anthropic.com>
</commit_message>
<xml_diff>
--- a/pitch/Del-Norte-Board-Approval.pptx
+++ b/pitch/Del-Norte-Board-Approval.pptx
@@ -1350,14 +1350,13 @@
         </p:nvPicPr>
         <p:blipFill>
           <a:blip r:embed="rId1"/>
-          <a:stretch>
-            <a:fillRect/>
-          </a:stretch>
+          <a:srcRect l="0" r="0" t="0" b="0"/>
+          <a:stretch/>
         </p:blipFill>
         <p:spPr>
           <a:xfrm>
-            <a:off x="7772400" y="457200"/>
-            <a:ext cx="822960" cy="822960"/>
+            <a:off x="6858000" y="274320"/>
+            <a:ext cx="2011680" cy="1188720"/>
           </a:xfrm>
           <a:prstGeom prst="rect">
             <a:avLst/>
@@ -4329,14 +4328,13 @@
         </p:nvPicPr>
         <p:blipFill>
           <a:blip r:embed="rId1"/>
-          <a:stretch>
-            <a:fillRect/>
-          </a:stretch>
+          <a:srcRect l="0" r="0" t="0" b="0"/>
+          <a:stretch/>
         </p:blipFill>
         <p:spPr>
           <a:xfrm>
-            <a:off x="4023360" y="731520"/>
-            <a:ext cx="1097280" cy="1097280"/>
+            <a:off x="3200400" y="365760"/>
+            <a:ext cx="2743200" cy="1645920"/>
           </a:xfrm>
           <a:prstGeom prst="rect">
             <a:avLst/>

</xml_diff>